<commit_message>
(1) Modified MetronomeApp so it implements _createViewManager() method, as required by update to tkAppFramework library. (2) Fixed bug in tkMetronomeViewManager causing MetronomeBpmWidget to not initialize with the Metronome business object's rhythm string. (3) Fixed Documentation/UI_WireFrame.pptx, since it was still the wireframe for the cribbage app. (4) Added README.txt documentation file, which still needs additions, and needs to be renamed README.md in a future commit.
</commit_message>
<xml_diff>
--- a/Documentation/UI_WireFrame.pptx
+++ b/Documentation/UI_WireFrame.pptx
@@ -5,11 +5,10 @@
     <p:sldMasterId id="2147483648" r:id="rId1"/>
   </p:sldMasterIdLst>
   <p:notesMasterIdLst>
-    <p:notesMasterId r:id="rId4"/>
+    <p:notesMasterId r:id="rId3"/>
   </p:notesMasterIdLst>
   <p:sldIdLst>
-    <p:sldId id="260" r:id="rId2"/>
-    <p:sldId id="259" r:id="rId3"/>
+    <p:sldId id="261" r:id="rId2"/>
   </p:sldIdLst>
   <p:sldSz cx="12192000" cy="6858000"/>
   <p:notesSz cx="6858000" cy="9144000"/>
@@ -198,7 +197,7 @@
           <a:p>
             <a:fld id="{F7C385A1-E043-4DEF-AF57-D24C6CB71DAC}" type="datetimeFigureOut">
               <a:rPr lang="en-US" smtClean="0"/>
-              <a:t>5/21/2024</a:t>
+              <a:t>9/18/2025</a:t>
             </a:fld>
             <a:endParaRPr lang="en-US"/>
           </a:p>
@@ -470,7 +469,13 @@
   <p:cSld>
     <p:spTree>
       <p:nvGrpSpPr>
-        <p:cNvPr id="1" name=""/>
+        <p:cNvPr id="1" name="">
+          <a:extLst>
+            <a:ext uri="{FF2B5EF4-FFF2-40B4-BE49-F238E27FC236}">
+              <a16:creationId xmlns:a16="http://schemas.microsoft.com/office/drawing/2014/main" id="{2B8EAC7C-1A9C-7122-9DAC-71E71DE83B78}"/>
+            </a:ext>
+          </a:extLst>
+        </p:cNvPr>
         <p:cNvGrpSpPr/>
         <p:nvPr/>
       </p:nvGrpSpPr>
@@ -484,7 +489,13 @@
       </p:grpSpPr>
       <p:sp>
         <p:nvSpPr>
-          <p:cNvPr id="2" name="Slide Image Placeholder 1"/>
+          <p:cNvPr id="2" name="Slide Image Placeholder 1">
+            <a:extLst>
+              <a:ext uri="{FF2B5EF4-FFF2-40B4-BE49-F238E27FC236}">
+                <a16:creationId xmlns:a16="http://schemas.microsoft.com/office/drawing/2014/main" id="{8A9C525D-D970-4830-0505-A9D199D50010}"/>
+              </a:ext>
+            </a:extLst>
+          </p:cNvPr>
           <p:cNvSpPr>
             <a:spLocks noGrp="1" noRot="1" noChangeAspect="1"/>
           </p:cNvSpPr>
@@ -496,7 +507,13 @@
       </p:sp>
       <p:sp>
         <p:nvSpPr>
-          <p:cNvPr id="3" name="Notes Placeholder 2"/>
+          <p:cNvPr id="3" name="Notes Placeholder 2">
+            <a:extLst>
+              <a:ext uri="{FF2B5EF4-FFF2-40B4-BE49-F238E27FC236}">
+                <a16:creationId xmlns:a16="http://schemas.microsoft.com/office/drawing/2014/main" id="{D3454342-3632-CAD8-2DD7-870B874780ED}"/>
+              </a:ext>
+            </a:extLst>
+          </p:cNvPr>
           <p:cNvSpPr>
             <a:spLocks noGrp="1"/>
           </p:cNvSpPr>
@@ -511,7 +528,15 @@
           <a:p>
             <a:r>
               <a:rPr lang="en-US" dirty="0"/>
-              <a:t>Grid-0 is the grid of the main application window or the root. The app is a </a:t>
+              <a:t>Grid-0 is the grid of the main application window or the root. The app (</a:t>
+            </a:r>
+            <a:r>
+              <a:rPr lang="en-US" dirty="0" err="1"/>
+              <a:t>MetronomeApp</a:t>
+            </a:r>
+            <a:r>
+              <a:rPr lang="en-US" dirty="0"/>
+              <a:t> class) is a </a:t>
             </a:r>
             <a:r>
               <a:rPr lang="en-US" dirty="0" err="1"/>
@@ -528,183 +553,105 @@
           <a:p>
             <a:r>
               <a:rPr lang="en-US" dirty="0"/>
-              <a:t>Grid-1 is the grid for the app. Onto it are gridded the Query </a:t>
+              <a:t>Grid-1 is the grid for the view manager (</a:t>
             </a:r>
             <a:r>
               <a:rPr lang="en-US" dirty="0" err="1"/>
-              <a:t>LabelFrame</a:t>
+              <a:t>tkMetronomeViewManager</a:t>
             </a:r>
             <a:r>
               <a:rPr lang="en-US" dirty="0"/>
-              <a:t> (owned by a </a:t>
+              <a:t> class). Onto it are gridded the </a:t>
             </a:r>
             <a:r>
               <a:rPr lang="en-US" dirty="0" err="1"/>
-              <a:t>QueryWidget</a:t>
+              <a:t>MetronomeBPMWidget</a:t>
             </a:r>
             <a:r>
               <a:rPr lang="en-US" dirty="0"/>
-              <a:t> object) and the “Results” Frame (owned by the </a:t>
+              <a:t>, </a:t>
             </a:r>
             <a:r>
               <a:rPr lang="en-US" dirty="0" err="1"/>
-              <a:t>tkWindowManager</a:t>
+              <a:t>MetronomeBeaconWidget</a:t>
             </a:r>
             <a:r>
               <a:rPr lang="en-US" dirty="0"/>
-              <a:t> object). The Results Frame is the </a:t>
+              <a:t>, </a:t>
             </a:r>
             <a:r>
               <a:rPr lang="en-US" dirty="0" err="1"/>
-              <a:t>unlabled</a:t>
+              <a:t>MetronomeRhythmWidget</a:t>
             </a:r>
             <a:r>
               <a:rPr lang="en-US" dirty="0"/>
-              <a:t>, dotted rectangle on the slide.</a:t>
+              <a:t>, and </a:t>
+            </a:r>
+            <a:r>
+              <a:rPr lang="en-US" dirty="0" err="1"/>
+              <a:t>MetronomeStartStopWidget</a:t>
+            </a:r>
+            <a:r>
+              <a:rPr lang="en-US" dirty="0"/>
+              <a:t> classes, all of which are </a:t>
+            </a:r>
+            <a:r>
+              <a:rPr lang="en-US" dirty="0" err="1"/>
+              <a:t>ttk.LabelFrames</a:t>
+            </a:r>
+            <a:r>
+              <a:rPr lang="en-US" dirty="0"/>
+              <a:t>.</a:t>
             </a:r>
           </a:p>
           <a:p>
             <a:endParaRPr lang="en-US" dirty="0"/>
           </a:p>
           <a:p>
-            <a:endParaRPr lang="en-US" dirty="0"/>
-          </a:p>
-          <a:p>
-            <a:pPr marL="0" marR="0" lvl="0" indent="0" algn="l" defTabSz="914400" rtl="0" eaLnBrk="1" fontAlgn="auto" latinLnBrk="0" hangingPunct="1">
-              <a:lnSpc>
-                <a:spcPct val="100000"/>
-              </a:lnSpc>
-              <a:spcBef>
-                <a:spcPts val="0"/>
-              </a:spcBef>
-              <a:spcAft>
-                <a:spcPts val="0"/>
-              </a:spcAft>
-              <a:buClrTx/>
-              <a:buSzTx/>
-              <a:buFontTx/>
-              <a:buNone/>
-              <a:tabLst/>
-              <a:defRPr/>
-            </a:pPr>
-            <a:r>
-              <a:rPr lang="en-US" dirty="0"/>
-              <a:t>The Query widget will handle all user response requests from </a:t>
-            </a:r>
-            <a:r>
-              <a:rPr lang="en-US" dirty="0" err="1"/>
-              <a:t>tkUserResponseCollector</a:t>
-            </a:r>
-            <a:r>
-              <a:rPr lang="en-US" dirty="0"/>
-              <a:t> global object. It will configure itself based on query events and query queue content received from the </a:t>
-            </a:r>
-            <a:r>
-              <a:rPr lang="en-US" dirty="0" err="1"/>
-              <a:t>CribbageGame</a:t>
-            </a:r>
-            <a:r>
-              <a:rPr lang="en-US" dirty="0"/>
-              <a:t>. And in response to user interaction with Query child widgets, it will place a response to the query event into the response queue of the </a:t>
-            </a:r>
-            <a:r>
-              <a:rPr lang="en-US" dirty="0" err="1"/>
-              <a:t>tkUserResponseCollector</a:t>
-            </a:r>
-            <a:r>
-              <a:rPr lang="en-US" dirty="0"/>
-              <a:t> global object. It will then appropriately clear / disable it’s child widgets until a new query event is received. The Query widget will not itself update any widgets owned by the “results” Frame, such as the board, starter, crib, hand, pile, and info. Instead, these widgets will be updated b the </a:t>
-            </a:r>
-            <a:r>
-              <a:rPr lang="en-US" dirty="0" err="1"/>
-              <a:t>tkWindowManager</a:t>
-            </a:r>
-            <a:r>
-              <a:rPr lang="en-US" dirty="0"/>
-              <a:t> mediator receiving output events from the </a:t>
-            </a:r>
-            <a:r>
-              <a:rPr lang="en-US" dirty="0" err="1"/>
-              <a:t>CribbageGame</a:t>
-            </a:r>
-            <a:r>
-              <a:rPr lang="en-US" dirty="0"/>
-              <a:t>. All of this is consistent with the “inversion” of control that happens once </a:t>
-            </a:r>
-            <a:r>
-              <a:rPr lang="en-US" dirty="0" err="1"/>
-              <a:t>CribbageGame.play</a:t>
-            </a:r>
-            <a:r>
-              <a:rPr lang="en-US" dirty="0"/>
-              <a:t>() is called. That is, at that point, the game is determining what happens next, not the app.</a:t>
-            </a:r>
-          </a:p>
-          <a:p>
-            <a:pPr marL="0" marR="0" lvl="0" indent="0" algn="l" defTabSz="914400" rtl="0" eaLnBrk="1" fontAlgn="auto" latinLnBrk="0" hangingPunct="1">
-              <a:lnSpc>
-                <a:spcPct val="100000"/>
-              </a:lnSpc>
-              <a:spcBef>
-                <a:spcPts val="0"/>
-              </a:spcBef>
-              <a:spcAft>
-                <a:spcPts val="0"/>
-              </a:spcAft>
-              <a:buClrTx/>
-              <a:buSzTx/>
-              <a:buFontTx/>
-              <a:buNone/>
-              <a:tabLst/>
-              <a:defRPr/>
-            </a:pPr>
-            <a:endParaRPr lang="en-US" dirty="0"/>
-          </a:p>
-          <a:p>
-            <a:pPr marL="0" marR="0" lvl="0" indent="0" algn="l" defTabSz="914400" rtl="0" eaLnBrk="1" fontAlgn="auto" latinLnBrk="0" hangingPunct="1">
-              <a:lnSpc>
-                <a:spcPct val="100000"/>
-              </a:lnSpc>
-              <a:spcBef>
-                <a:spcPts val="0"/>
-              </a:spcBef>
-              <a:spcAft>
-                <a:spcPts val="0"/>
-              </a:spcAft>
-              <a:buClrTx/>
-              <a:buSzTx/>
-              <a:buFontTx/>
-              <a:buNone/>
-              <a:tabLst/>
-              <a:defRPr/>
-            </a:pPr>
             <a:r>
               <a:rPr lang="en-US" dirty="0"/>
               <a:t>The </a:t>
             </a:r>
             <a:r>
               <a:rPr lang="en-US" dirty="0" err="1"/>
-              <a:t>tkWindowManager</a:t>
+              <a:t>MetronomeBeaconWidget</a:t>
             </a:r>
             <a:r>
               <a:rPr lang="en-US" dirty="0"/>
-              <a:t>, following a  mediator design pattern, will be used to manage the Player 1 Hand, the Crib, and the Play Pile. These are not strictly speaking “interactions”, however, as all of these widgets only visualize results received from the </a:t>
+              <a:t> contains a </a:t>
             </a:r>
             <a:r>
               <a:rPr lang="en-US" dirty="0" err="1"/>
-              <a:t>CribbageGame</a:t>
+              <a:t>tk.Button</a:t>
             </a:r>
             <a:r>
               <a:rPr lang="en-US" dirty="0"/>
-              <a:t>. For example, when the </a:t>
+              <a:t>. It’s color will be red during a stressed beat of the metronome, green during an unstressed beat, and black when the metronome is in between beats or stopped.</a:t>
+            </a:r>
+          </a:p>
+          <a:p>
+            <a:endParaRPr lang="en-US" dirty="0"/>
+          </a:p>
+          <a:p>
+            <a:r>
+              <a:rPr lang="en-US" dirty="0"/>
+              <a:t>The </a:t>
             </a:r>
             <a:r>
               <a:rPr lang="en-US" dirty="0" err="1"/>
-              <a:t>CribbageGame</a:t>
+              <a:t>MetronomeRhythmWidget</a:t>
             </a:r>
             <a:r>
               <a:rPr lang="en-US" dirty="0"/>
-              <a:t> sends as message that a card has been played, the “face up” cards (buttons) in the Player 1 Hand will be adjusted by changing text, and/or hiding. And the Play Pile will be similarly adjusted. This mediator will also be responsible for “turning over” the crib cards by adding text to them when it is time to show the crib.</a:t>
+              <a:t> contains a </a:t>
+            </a:r>
+            <a:r>
+              <a:rPr lang="en-US" dirty="0" err="1"/>
+              <a:t>ttk.Entry</a:t>
+            </a:r>
+            <a:r>
+              <a:rPr lang="en-US" dirty="0"/>
+              <a:t> object. It will be disabled when the metronome is started and enabled when the metronome is stopped.</a:t>
             </a:r>
           </a:p>
           <a:p>
@@ -713,7 +660,23 @@
           <a:p>
             <a:r>
               <a:rPr lang="en-US" dirty="0"/>
-              <a:t>The menu of the application will initially be very simple: Start Game | End Game | Exit</a:t>
+              <a:t>The </a:t>
+            </a:r>
+            <a:r>
+              <a:rPr lang="en-US" dirty="0" err="1"/>
+              <a:t>MetronomeStartStopWidgety</a:t>
+            </a:r>
+            <a:r>
+              <a:rPr lang="en-US" dirty="0"/>
+              <a:t> contains a </a:t>
+            </a:r>
+            <a:r>
+              <a:rPr lang="en-US" dirty="0" err="1"/>
+              <a:t>ttk.Button</a:t>
+            </a:r>
+            <a:r>
+              <a:rPr lang="en-US" dirty="0"/>
+              <a:t> object. When the metronome is stopped, the button’s text will be “Start”. When the metronome is started, the button’s text will be “Stop”.</a:t>
             </a:r>
           </a:p>
           <a:p>
@@ -722,40 +685,41 @@
           <a:p>
             <a:r>
               <a:rPr lang="en-US" dirty="0"/>
-              <a:t>Will probably want to have python classes to represent, besides the App, the Cribbage Board (for sure), Starter (maybe), Crib (likely), Hand (for sure), Play Pile (for sure), Play/Show Score Info (maybe)</a:t>
+              <a:t>The menu of the application will be as follows:</a:t>
+            </a:r>
+          </a:p>
+          <a:p>
+            <a:r>
+              <a:rPr lang="en-US" dirty="0"/>
+              <a:t>File | Exit</a:t>
+            </a:r>
+          </a:p>
+          <a:p>
+            <a:r>
+              <a:rPr lang="en-US" dirty="0"/>
+              <a:t>Help | View Help</a:t>
+            </a:r>
+          </a:p>
+          <a:p>
+            <a:r>
+              <a:rPr lang="en-US" dirty="0"/>
+              <a:t>Help | About…</a:t>
             </a:r>
           </a:p>
           <a:p>
             <a:endParaRPr lang="en-US" dirty="0"/>
           </a:p>
-          <a:p>
-            <a:r>
-              <a:rPr lang="en-US" dirty="0"/>
-              <a:t>Player 1 Hand must have up to 6 card buttons shown, for immediately after deal and before crib is formed.</a:t>
-            </a:r>
-          </a:p>
-          <a:p>
-            <a:endParaRPr lang="en-US" dirty="0"/>
-          </a:p>
-          <a:p>
-            <a:r>
-              <a:rPr lang="en-US" dirty="0"/>
-              <a:t>In the event that 9 cards buttons are not enough for the Play Pile, would probably just “rotate” text and let the oldest cards “disappear”. Could add the text for the </a:t>
-            </a:r>
-            <a:r>
-              <a:rPr lang="en-US" dirty="0" err="1"/>
-              <a:t>disappeard</a:t>
-            </a:r>
-            <a:r>
-              <a:rPr lang="en-US" dirty="0"/>
-              <a:t> cards to the label frame text, or make the first card button represent multiple cards and change it’s text accordingly.</a:t>
-            </a:r>
-          </a:p>
-        </p:txBody>
-      </p:sp>
-      <p:sp>
-        <p:nvSpPr>
-          <p:cNvPr id="4" name="Slide Number Placeholder 3"/>
+        </p:txBody>
+      </p:sp>
+      <p:sp>
+        <p:nvSpPr>
+          <p:cNvPr id="4" name="Slide Number Placeholder 3">
+            <a:extLst>
+              <a:ext uri="{FF2B5EF4-FFF2-40B4-BE49-F238E27FC236}">
+                <a16:creationId xmlns:a16="http://schemas.microsoft.com/office/drawing/2014/main" id="{125E3DBA-F2A8-FBF2-24AF-76C06A560E76}"/>
+              </a:ext>
+            </a:extLst>
+          </p:cNvPr>
           <p:cNvSpPr>
             <a:spLocks noGrp="1"/>
           </p:cNvSpPr>
@@ -770,7 +734,7 @@
           <a:p>
             <a:fld id="{F8C89F3F-441F-4A04-A2D5-EBB32987D003}" type="slidenum">
               <a:rPr lang="en-US" smtClean="0"/>
-              <a:t>2</a:t>
+              <a:t>1</a:t>
             </a:fld>
             <a:endParaRPr lang="en-US"/>
           </a:p>
@@ -779,7 +743,7 @@
     </p:spTree>
     <p:extLst>
       <p:ext uri="{BB962C8B-B14F-4D97-AF65-F5344CB8AC3E}">
-        <p14:creationId xmlns:p14="http://schemas.microsoft.com/office/powerpoint/2010/main" val="356302480"/>
+        <p14:creationId xmlns:p14="http://schemas.microsoft.com/office/powerpoint/2010/main" val="106565913"/>
       </p:ext>
     </p:extLst>
   </p:cSld>
@@ -936,7 +900,7 @@
           <a:p>
             <a:fld id="{4870612B-B7BB-4E5D-BC34-D71D50577435}" type="datetimeFigureOut">
               <a:rPr lang="en-US" smtClean="0"/>
-              <a:t>5/21/2024</a:t>
+              <a:t>9/18/2025</a:t>
             </a:fld>
             <a:endParaRPr lang="en-US"/>
           </a:p>
@@ -1134,7 +1098,7 @@
           <a:p>
             <a:fld id="{4870612B-B7BB-4E5D-BC34-D71D50577435}" type="datetimeFigureOut">
               <a:rPr lang="en-US" smtClean="0"/>
-              <a:t>5/21/2024</a:t>
+              <a:t>9/18/2025</a:t>
             </a:fld>
             <a:endParaRPr lang="en-US"/>
           </a:p>
@@ -1342,7 +1306,7 @@
           <a:p>
             <a:fld id="{4870612B-B7BB-4E5D-BC34-D71D50577435}" type="datetimeFigureOut">
               <a:rPr lang="en-US" smtClean="0"/>
-              <a:t>5/21/2024</a:t>
+              <a:t>9/18/2025</a:t>
             </a:fld>
             <a:endParaRPr lang="en-US"/>
           </a:p>
@@ -1540,7 +1504,7 @@
           <a:p>
             <a:fld id="{4870612B-B7BB-4E5D-BC34-D71D50577435}" type="datetimeFigureOut">
               <a:rPr lang="en-US" smtClean="0"/>
-              <a:t>5/21/2024</a:t>
+              <a:t>9/18/2025</a:t>
             </a:fld>
             <a:endParaRPr lang="en-US"/>
           </a:p>
@@ -1815,7 +1779,7 @@
           <a:p>
             <a:fld id="{4870612B-B7BB-4E5D-BC34-D71D50577435}" type="datetimeFigureOut">
               <a:rPr lang="en-US" smtClean="0"/>
-              <a:t>5/21/2024</a:t>
+              <a:t>9/18/2025</a:t>
             </a:fld>
             <a:endParaRPr lang="en-US"/>
           </a:p>
@@ -2080,7 +2044,7 @@
           <a:p>
             <a:fld id="{4870612B-B7BB-4E5D-BC34-D71D50577435}" type="datetimeFigureOut">
               <a:rPr lang="en-US" smtClean="0"/>
-              <a:t>5/21/2024</a:t>
+              <a:t>9/18/2025</a:t>
             </a:fld>
             <a:endParaRPr lang="en-US"/>
           </a:p>
@@ -2492,7 +2456,7 @@
           <a:p>
             <a:fld id="{4870612B-B7BB-4E5D-BC34-D71D50577435}" type="datetimeFigureOut">
               <a:rPr lang="en-US" smtClean="0"/>
-              <a:t>5/21/2024</a:t>
+              <a:t>9/18/2025</a:t>
             </a:fld>
             <a:endParaRPr lang="en-US"/>
           </a:p>
@@ -2633,7 +2597,7 @@
           <a:p>
             <a:fld id="{4870612B-B7BB-4E5D-BC34-D71D50577435}" type="datetimeFigureOut">
               <a:rPr lang="en-US" smtClean="0"/>
-              <a:t>5/21/2024</a:t>
+              <a:t>9/18/2025</a:t>
             </a:fld>
             <a:endParaRPr lang="en-US"/>
           </a:p>
@@ -2746,7 +2710,7 @@
           <a:p>
             <a:fld id="{4870612B-B7BB-4E5D-BC34-D71D50577435}" type="datetimeFigureOut">
               <a:rPr lang="en-US" smtClean="0"/>
-              <a:t>5/21/2024</a:t>
+              <a:t>9/18/2025</a:t>
             </a:fld>
             <a:endParaRPr lang="en-US"/>
           </a:p>
@@ -3057,7 +3021,7 @@
           <a:p>
             <a:fld id="{4870612B-B7BB-4E5D-BC34-D71D50577435}" type="datetimeFigureOut">
               <a:rPr lang="en-US" smtClean="0"/>
-              <a:t>5/21/2024</a:t>
+              <a:t>9/18/2025</a:t>
             </a:fld>
             <a:endParaRPr lang="en-US"/>
           </a:p>
@@ -3345,7 +3309,7 @@
           <a:p>
             <a:fld id="{4870612B-B7BB-4E5D-BC34-D71D50577435}" type="datetimeFigureOut">
               <a:rPr lang="en-US" smtClean="0"/>
-              <a:t>5/21/2024</a:t>
+              <a:t>9/18/2025</a:t>
             </a:fld>
             <a:endParaRPr lang="en-US"/>
           </a:p>
@@ -3586,7 +3550,7 @@
           <a:p>
             <a:fld id="{4870612B-B7BB-4E5D-BC34-D71D50577435}" type="datetimeFigureOut">
               <a:rPr lang="en-US" smtClean="0"/>
-              <a:t>5/21/2024</a:t>
+              <a:t>9/18/2025</a:t>
             </a:fld>
             <a:endParaRPr lang="en-US"/>
           </a:p>
@@ -3991,7 +3955,13 @@
   <p:cSld>
     <p:spTree>
       <p:nvGrpSpPr>
-        <p:cNvPr id="1" name=""/>
+        <p:cNvPr id="1" name="">
+          <a:extLst>
+            <a:ext uri="{FF2B5EF4-FFF2-40B4-BE49-F238E27FC236}">
+              <a16:creationId xmlns:a16="http://schemas.microsoft.com/office/drawing/2014/main" id="{B58B9E46-DE17-DC09-2C2A-331F5587669B}"/>
+            </a:ext>
+          </a:extLst>
+        </p:cNvPr>
         <p:cNvGrpSpPr/>
         <p:nvPr/>
       </p:nvGrpSpPr>
@@ -4003,42 +3973,12 @@
           <a:chExt cx="0" cy="0"/>
         </a:xfrm>
       </p:grpSpPr>
-    </p:spTree>
-    <p:extLst>
-      <p:ext uri="{BB962C8B-B14F-4D97-AF65-F5344CB8AC3E}">
-        <p14:creationId xmlns:p14="http://schemas.microsoft.com/office/powerpoint/2010/main" val="1375365489"/>
-      </p:ext>
-    </p:extLst>
-  </p:cSld>
-  <p:clrMapOvr>
-    <a:masterClrMapping/>
-  </p:clrMapOvr>
-</p:sld>
-</file>
-
-<file path=ppt/slides/slide2.xml><?xml version="1.0" encoding="utf-8"?>
-<p:sld xmlns:a="http://schemas.openxmlformats.org/drawingml/2006/main" xmlns:r="http://schemas.openxmlformats.org/officeDocument/2006/relationships" xmlns:p="http://schemas.openxmlformats.org/presentationml/2006/main">
-  <p:cSld>
-    <p:spTree>
-      <p:nvGrpSpPr>
-        <p:cNvPr id="1" name=""/>
-        <p:cNvGrpSpPr/>
-        <p:nvPr/>
-      </p:nvGrpSpPr>
-      <p:grpSpPr>
-        <a:xfrm>
-          <a:off x="0" y="0"/>
-          <a:ext cx="0" cy="0"/>
-          <a:chOff x="0" y="0"/>
-          <a:chExt cx="0" cy="0"/>
-        </a:xfrm>
-      </p:grpSpPr>
-      <p:sp>
-        <p:nvSpPr>
-          <p:cNvPr id="17" name="TextBox 16">
-            <a:extLst>
-              <a:ext uri="{FF2B5EF4-FFF2-40B4-BE49-F238E27FC236}">
-                <a16:creationId xmlns:a16="http://schemas.microsoft.com/office/drawing/2014/main" id="{BF698E90-4AE0-19DC-14E0-F90A6E032C64}"/>
+      <p:sp>
+        <p:nvSpPr>
+          <p:cNvPr id="2" name="TextBox 1">
+            <a:extLst>
+              <a:ext uri="{FF2B5EF4-FFF2-40B4-BE49-F238E27FC236}">
+                <a16:creationId xmlns:a16="http://schemas.microsoft.com/office/drawing/2014/main" id="{F3CCF473-A2BE-6507-DE6D-0BEEFC832AC9}"/>
               </a:ext>
             </a:extLst>
           </p:cNvPr>
@@ -4047,8 +3987,8 @@
         </p:nvSpPr>
         <p:spPr>
           <a:xfrm>
-            <a:off x="7860480" y="111509"/>
-            <a:ext cx="4171611" cy="1872887"/>
+            <a:off x="3287984" y="109729"/>
+            <a:ext cx="2745975" cy="4233671"/>
           </a:xfrm>
           <a:prstGeom prst="rect">
             <a:avLst/>
@@ -4068,175 +4008,7 @@
           <a:p>
             <a:r>
               <a:rPr lang="en-US" dirty="0"/>
-              <a:t>Crib</a:t>
-            </a:r>
-          </a:p>
-        </p:txBody>
-      </p:sp>
-      <p:sp>
-        <p:nvSpPr>
-          <p:cNvPr id="19" name="TextBox 18">
-            <a:extLst>
-              <a:ext uri="{FF2B5EF4-FFF2-40B4-BE49-F238E27FC236}">
-                <a16:creationId xmlns:a16="http://schemas.microsoft.com/office/drawing/2014/main" id="{13D24BEB-1077-EA53-A6A3-5EEB39BD46FF}"/>
-              </a:ext>
-            </a:extLst>
-          </p:cNvPr>
-          <p:cNvSpPr txBox="1"/>
-          <p:nvPr/>
-        </p:nvSpPr>
-        <p:spPr>
-          <a:xfrm>
-            <a:off x="6031508" y="1987606"/>
-            <a:ext cx="6000584" cy="1687051"/>
-          </a:xfrm>
-          <a:prstGeom prst="rect">
-            <a:avLst/>
-          </a:prstGeom>
-          <a:noFill/>
-          <a:ln>
-            <a:solidFill>
-              <a:schemeClr val="accent1"/>
-            </a:solidFill>
-          </a:ln>
-        </p:spPr>
-        <p:txBody>
-          <a:bodyPr wrap="square" rtlCol="0">
-            <a:noAutofit/>
-          </a:bodyPr>
-          <a:lstStyle/>
-          <a:p>
-            <a:r>
-              <a:rPr lang="en-US" dirty="0"/>
-              <a:t>Player 1 Hand – </a:t>
-            </a:r>
-            <a:r>
-              <a:rPr lang="en-US" dirty="0">
-                <a:solidFill>
-                  <a:schemeClr val="accent3"/>
-                </a:solidFill>
-              </a:rPr>
-              <a:t>Click card to add to crib / play</a:t>
-            </a:r>
-          </a:p>
-        </p:txBody>
-      </p:sp>
-      <p:sp>
-        <p:nvSpPr>
-          <p:cNvPr id="18" name="TextBox 17">
-            <a:extLst>
-              <a:ext uri="{FF2B5EF4-FFF2-40B4-BE49-F238E27FC236}">
-                <a16:creationId xmlns:a16="http://schemas.microsoft.com/office/drawing/2014/main" id="{F8FF0499-6379-C3D2-F6BE-EDF15B22F758}"/>
-              </a:ext>
-            </a:extLst>
-          </p:cNvPr>
-          <p:cNvSpPr txBox="1"/>
-          <p:nvPr/>
-        </p:nvSpPr>
-        <p:spPr>
-          <a:xfrm>
-            <a:off x="5985530" y="3678866"/>
-            <a:ext cx="6025355" cy="1697355"/>
-          </a:xfrm>
-          <a:prstGeom prst="rect">
-            <a:avLst/>
-          </a:prstGeom>
-          <a:noFill/>
-          <a:ln>
-            <a:solidFill>
-              <a:schemeClr val="accent1"/>
-            </a:solidFill>
-          </a:ln>
-        </p:spPr>
-        <p:txBody>
-          <a:bodyPr wrap="square" rtlCol="0">
-            <a:noAutofit/>
-          </a:bodyPr>
-          <a:lstStyle/>
-          <a:p>
-            <a:r>
-              <a:rPr lang="en-US" dirty="0"/>
-              <a:t>Play Pile</a:t>
-            </a:r>
-          </a:p>
-        </p:txBody>
-      </p:sp>
-      <p:sp>
-        <p:nvSpPr>
-          <p:cNvPr id="10" name="TextBox 9">
-            <a:extLst>
-              <a:ext uri="{FF2B5EF4-FFF2-40B4-BE49-F238E27FC236}">
-                <a16:creationId xmlns:a16="http://schemas.microsoft.com/office/drawing/2014/main" id="{D1EF0CA6-FC74-1EAD-7BEC-0611F046700E}"/>
-              </a:ext>
-            </a:extLst>
-          </p:cNvPr>
-          <p:cNvSpPr txBox="1"/>
-          <p:nvPr/>
-        </p:nvSpPr>
-        <p:spPr>
-          <a:xfrm>
-            <a:off x="6053452" y="109728"/>
-            <a:ext cx="1787535" cy="1881116"/>
-          </a:xfrm>
-          <a:prstGeom prst="rect">
-            <a:avLst/>
-          </a:prstGeom>
-          <a:noFill/>
-          <a:ln>
-            <a:solidFill>
-              <a:schemeClr val="accent1"/>
-            </a:solidFill>
-          </a:ln>
-        </p:spPr>
-        <p:txBody>
-          <a:bodyPr wrap="square" rtlCol="0">
-            <a:noAutofit/>
-          </a:bodyPr>
-          <a:lstStyle/>
-          <a:p>
-            <a:r>
-              <a:rPr lang="en-US" dirty="0"/>
-              <a:t>Starter</a:t>
-            </a:r>
-          </a:p>
-        </p:txBody>
-      </p:sp>
-      <p:sp>
-        <p:nvSpPr>
-          <p:cNvPr id="2" name="TextBox 1">
-            <a:extLst>
-              <a:ext uri="{FF2B5EF4-FFF2-40B4-BE49-F238E27FC236}">
-                <a16:creationId xmlns:a16="http://schemas.microsoft.com/office/drawing/2014/main" id="{AEEE1016-557E-41E8-AF7F-CCABD372BDAD}"/>
-              </a:ext>
-            </a:extLst>
-          </p:cNvPr>
-          <p:cNvSpPr txBox="1"/>
-          <p:nvPr/>
-        </p:nvSpPr>
-        <p:spPr>
-          <a:xfrm>
-            <a:off x="3287984" y="109729"/>
-            <a:ext cx="2745975" cy="6509970"/>
-          </a:xfrm>
-          <a:prstGeom prst="rect">
-            <a:avLst/>
-          </a:prstGeom>
-          <a:noFill/>
-          <a:ln>
-            <a:solidFill>
-              <a:schemeClr val="accent1"/>
-            </a:solidFill>
-          </a:ln>
-        </p:spPr>
-        <p:txBody>
-          <a:bodyPr wrap="square" rtlCol="0">
-            <a:noAutofit/>
-          </a:bodyPr>
-          <a:lstStyle/>
-          <a:p>
-            <a:r>
-              <a:rPr lang="en-US" dirty="0"/>
-              <a:t>Cribbage Board</a:t>
+              <a:t>Beacon</a:t>
             </a:r>
           </a:p>
         </p:txBody>
@@ -4246,7 +4018,7 @@
           <p:cNvPr id="7" name="TextBox 6">
             <a:extLst>
               <a:ext uri="{FF2B5EF4-FFF2-40B4-BE49-F238E27FC236}">
-                <a16:creationId xmlns:a16="http://schemas.microsoft.com/office/drawing/2014/main" id="{18D929B4-F003-4B45-B625-F14619D054E9}"/>
+                <a16:creationId xmlns:a16="http://schemas.microsoft.com/office/drawing/2014/main" id="{E5A0B4FD-544B-7B25-FFB1-635A00F33166}"/>
               </a:ext>
             </a:extLst>
           </p:cNvPr>
@@ -4275,17 +4047,17 @@
                   <a:srgbClr val="FF0000"/>
                 </a:solidFill>
               </a:rPr>
-              <a:t>Grid-2 (0-3,0)</a:t>
-            </a:r>
-          </a:p>
-        </p:txBody>
-      </p:sp>
-      <p:sp>
-        <p:nvSpPr>
-          <p:cNvPr id="3" name="TextBox 2">
-            <a:extLst>
-              <a:ext uri="{FF2B5EF4-FFF2-40B4-BE49-F238E27FC236}">
-                <a16:creationId xmlns:a16="http://schemas.microsoft.com/office/drawing/2014/main" id="{51AAD25F-6AB7-1B9F-D475-FC50B9523C98}"/>
+              <a:t>Grid-2 (0,1)</a:t>
+            </a:r>
+          </a:p>
+        </p:txBody>
+      </p:sp>
+      <p:sp>
+        <p:nvSpPr>
+          <p:cNvPr id="5" name="TextBox 4">
+            <a:extLst>
+              <a:ext uri="{FF2B5EF4-FFF2-40B4-BE49-F238E27FC236}">
+                <a16:creationId xmlns:a16="http://schemas.microsoft.com/office/drawing/2014/main" id="{16FCD1E3-04DF-E136-BD64-D67A5C648C5F}"/>
               </a:ext>
             </a:extLst>
           </p:cNvPr>
@@ -4294,55 +4066,7 @@
         </p:nvSpPr>
         <p:spPr>
           <a:xfrm>
-            <a:off x="3287984" y="532182"/>
-            <a:ext cx="1348773" cy="6087517"/>
-          </a:xfrm>
-          <a:prstGeom prst="rect">
-            <a:avLst/>
-          </a:prstGeom>
-          <a:noFill/>
-          <a:ln>
-            <a:solidFill>
-              <a:schemeClr val="accent1"/>
-            </a:solidFill>
-          </a:ln>
-        </p:spPr>
-        <p:txBody>
-          <a:bodyPr wrap="square" rtlCol="0">
-            <a:noAutofit/>
-          </a:bodyPr>
-          <a:lstStyle/>
-          <a:p>
-            <a:r>
-              <a:rPr lang="en-US" dirty="0"/>
-              <a:t>Player 1 - </a:t>
-            </a:r>
-            <a:r>
-              <a:rPr lang="en-US" dirty="0">
-                <a:solidFill>
-                  <a:schemeClr val="accent3"/>
-                </a:solidFill>
-              </a:rPr>
-              <a:t>Dealer</a:t>
-            </a:r>
-          </a:p>
-        </p:txBody>
-      </p:sp>
-      <p:sp>
-        <p:nvSpPr>
-          <p:cNvPr id="5" name="TextBox 4">
-            <a:extLst>
-              <a:ext uri="{FF2B5EF4-FFF2-40B4-BE49-F238E27FC236}">
-                <a16:creationId xmlns:a16="http://schemas.microsoft.com/office/drawing/2014/main" id="{7387F187-1DC6-FD0F-E434-0E4A15F21FC4}"/>
-              </a:ext>
-            </a:extLst>
-          </p:cNvPr>
-          <p:cNvSpPr txBox="1"/>
-          <p:nvPr/>
-        </p:nvSpPr>
-        <p:spPr>
-          <a:xfrm>
-            <a:off x="3443119" y="1217881"/>
+            <a:off x="4169778" y="774216"/>
             <a:ext cx="899605" cy="276999"/>
           </a:xfrm>
           <a:prstGeom prst="rect">
@@ -4369,10 +4093,10 @@
       </p:sp>
       <p:sp>
         <p:nvSpPr>
-          <p:cNvPr id="8" name="TextBox 7">
-            <a:extLst>
-              <a:ext uri="{FF2B5EF4-FFF2-40B4-BE49-F238E27FC236}">
-                <a16:creationId xmlns:a16="http://schemas.microsoft.com/office/drawing/2014/main" id="{85E861E2-3C0B-B13C-FDFC-3FDAB49E840C}"/>
+          <p:cNvPr id="21" name="TextBox 20">
+            <a:extLst>
+              <a:ext uri="{FF2B5EF4-FFF2-40B4-BE49-F238E27FC236}">
+                <a16:creationId xmlns:a16="http://schemas.microsoft.com/office/drawing/2014/main" id="{3F0EFD7B-3C1A-038D-B5CD-8D9262CC94D1}"/>
               </a:ext>
             </a:extLst>
           </p:cNvPr>
@@ -4380,9 +4104,9 @@
           <p:nvPr/>
         </p:nvSpPr>
         <p:spPr>
-          <a:xfrm>
-            <a:off x="3298346" y="1955768"/>
-            <a:ext cx="1328048" cy="1015663"/>
+          <a:xfrm rot="16200000">
+            <a:off x="-669122" y="872590"/>
+            <a:ext cx="1844186" cy="461665"/>
           </a:xfrm>
           <a:prstGeom prst="rect">
             <a:avLst/>
@@ -4401,7 +4125,7 @@
                   <a:srgbClr val="FF0000"/>
                 </a:solidFill>
               </a:rPr>
-              <a:t>Peg holes are check boxes or radio buttons laid out on</a:t>
+              <a:t>Grid-0 (row=0,colum=0)</a:t>
             </a:r>
           </a:p>
           <a:p>
@@ -4411,1972 +4135,7 @@
                   <a:srgbClr val="FF0000"/>
                 </a:solidFill>
               </a:rPr>
-              <a:t>Grid-4 (0-31,0-1)</a:t>
-            </a:r>
-          </a:p>
-        </p:txBody>
-      </p:sp>
-      <p:sp>
-        <p:nvSpPr>
-          <p:cNvPr id="4" name="TextBox 3">
-            <a:extLst>
-              <a:ext uri="{FF2B5EF4-FFF2-40B4-BE49-F238E27FC236}">
-                <a16:creationId xmlns:a16="http://schemas.microsoft.com/office/drawing/2014/main" id="{CC06B1D9-60BA-2156-F65E-D1786AD95A00}"/>
-              </a:ext>
-            </a:extLst>
-          </p:cNvPr>
-          <p:cNvSpPr txBox="1"/>
-          <p:nvPr/>
-        </p:nvSpPr>
-        <p:spPr>
-          <a:xfrm>
-            <a:off x="4636757" y="532183"/>
-            <a:ext cx="1397202" cy="6087516"/>
-          </a:xfrm>
-          <a:prstGeom prst="rect">
-            <a:avLst/>
-          </a:prstGeom>
-          <a:noFill/>
-          <a:ln>
-            <a:solidFill>
-              <a:schemeClr val="accent1"/>
-            </a:solidFill>
-          </a:ln>
-        </p:spPr>
-        <p:txBody>
-          <a:bodyPr wrap="square" rtlCol="0">
-            <a:noAutofit/>
-          </a:bodyPr>
-          <a:lstStyle/>
-          <a:p>
-            <a:r>
-              <a:rPr lang="en-US" dirty="0"/>
-              <a:t>Player 2</a:t>
-            </a:r>
-          </a:p>
-        </p:txBody>
-      </p:sp>
-      <p:sp>
-        <p:nvSpPr>
-          <p:cNvPr id="6" name="TextBox 5">
-            <a:extLst>
-              <a:ext uri="{FF2B5EF4-FFF2-40B4-BE49-F238E27FC236}">
-                <a16:creationId xmlns:a16="http://schemas.microsoft.com/office/drawing/2014/main" id="{C9A7C3A3-A090-A23C-B9A5-D9D416AB0C75}"/>
-              </a:ext>
-            </a:extLst>
-          </p:cNvPr>
-          <p:cNvSpPr txBox="1"/>
-          <p:nvPr/>
-        </p:nvSpPr>
-        <p:spPr>
-          <a:xfrm>
-            <a:off x="4684551" y="884796"/>
-            <a:ext cx="899605" cy="276999"/>
-          </a:xfrm>
-          <a:prstGeom prst="rect">
-            <a:avLst/>
-          </a:prstGeom>
-          <a:noFill/>
-        </p:spPr>
-        <p:txBody>
-          <a:bodyPr wrap="none" rtlCol="0">
-            <a:spAutoFit/>
-          </a:bodyPr>
-          <a:lstStyle/>
-          <a:p>
-            <a:r>
-              <a:rPr lang="en-US" sz="1200" dirty="0">
-                <a:solidFill>
-                  <a:srgbClr val="FF0000"/>
-                </a:solidFill>
-              </a:rPr>
-              <a:t>Grid-3 (0,1)</a:t>
-            </a:r>
-          </a:p>
-        </p:txBody>
-      </p:sp>
-      <p:sp>
-        <p:nvSpPr>
-          <p:cNvPr id="9" name="TextBox 8">
-            <a:extLst>
-              <a:ext uri="{FF2B5EF4-FFF2-40B4-BE49-F238E27FC236}">
-                <a16:creationId xmlns:a16="http://schemas.microsoft.com/office/drawing/2014/main" id="{A4748B1C-42CB-6749-5293-A272457B47CE}"/>
-              </a:ext>
-            </a:extLst>
-          </p:cNvPr>
-          <p:cNvSpPr txBox="1"/>
-          <p:nvPr/>
-        </p:nvSpPr>
-        <p:spPr>
-          <a:xfrm>
-            <a:off x="4647118" y="1916184"/>
-            <a:ext cx="1328048" cy="1015663"/>
-          </a:xfrm>
-          <a:prstGeom prst="rect">
-            <a:avLst/>
-          </a:prstGeom>
-          <a:noFill/>
-        </p:spPr>
-        <p:txBody>
-          <a:bodyPr wrap="square" rtlCol="0">
-            <a:spAutoFit/>
-          </a:bodyPr>
-          <a:lstStyle/>
-          <a:p>
-            <a:r>
-              <a:rPr lang="en-US" sz="1200" dirty="0">
-                <a:solidFill>
-                  <a:srgbClr val="FF0000"/>
-                </a:solidFill>
-              </a:rPr>
-              <a:t>Peg holes are check boxes or radio buttons laid out on</a:t>
-            </a:r>
-          </a:p>
-          <a:p>
-            <a:r>
-              <a:rPr lang="en-US" sz="1200" dirty="0">
-                <a:solidFill>
-                  <a:srgbClr val="FF0000"/>
-                </a:solidFill>
-              </a:rPr>
-              <a:t>Grid-4 (0-31,0-1)</a:t>
-            </a:r>
-          </a:p>
-        </p:txBody>
-      </p:sp>
-      <p:sp>
-        <p:nvSpPr>
-          <p:cNvPr id="12" name="TextBox 11">
-            <a:extLst>
-              <a:ext uri="{FF2B5EF4-FFF2-40B4-BE49-F238E27FC236}">
-                <a16:creationId xmlns:a16="http://schemas.microsoft.com/office/drawing/2014/main" id="{ADB639DE-BEA3-F1E9-479E-B8A8A0138B4A}"/>
-              </a:ext>
-            </a:extLst>
-          </p:cNvPr>
-          <p:cNvSpPr txBox="1"/>
-          <p:nvPr/>
-        </p:nvSpPr>
-        <p:spPr>
-          <a:xfrm>
-            <a:off x="6745668" y="181331"/>
-            <a:ext cx="1073400" cy="276999"/>
-          </a:xfrm>
-          <a:prstGeom prst="rect">
-            <a:avLst/>
-          </a:prstGeom>
-          <a:noFill/>
-        </p:spPr>
-        <p:txBody>
-          <a:bodyPr wrap="square" rtlCol="0">
-            <a:spAutoFit/>
-          </a:bodyPr>
-          <a:lstStyle/>
-          <a:p>
-            <a:r>
-              <a:rPr lang="en-US" sz="1200" dirty="0">
-                <a:solidFill>
-                  <a:srgbClr val="FF0000"/>
-                </a:solidFill>
-              </a:rPr>
-              <a:t>Grid-2 (0,1)</a:t>
-            </a:r>
-          </a:p>
-        </p:txBody>
-      </p:sp>
-      <p:sp>
-        <p:nvSpPr>
-          <p:cNvPr id="11" name="Rectangle: Rounded Corners 10">
-            <a:extLst>
-              <a:ext uri="{FF2B5EF4-FFF2-40B4-BE49-F238E27FC236}">
-                <a16:creationId xmlns:a16="http://schemas.microsoft.com/office/drawing/2014/main" id="{CDA4FE90-C4E3-0485-A83C-632232729481}"/>
-              </a:ext>
-            </a:extLst>
-          </p:cNvPr>
-          <p:cNvSpPr/>
-          <p:nvPr/>
-        </p:nvSpPr>
-        <p:spPr>
-          <a:xfrm>
-            <a:off x="6205694" y="2274359"/>
-            <a:ext cx="891268" cy="1347825"/>
-          </a:xfrm>
-          <a:prstGeom prst="roundRect">
-            <a:avLst/>
-          </a:prstGeom>
-          <a:noFill/>
-        </p:spPr>
-        <p:style>
-          <a:lnRef idx="2">
-            <a:schemeClr val="accent1">
-              <a:shade val="15000"/>
-            </a:schemeClr>
-          </a:lnRef>
-          <a:fillRef idx="1">
-            <a:schemeClr val="accent1"/>
-          </a:fillRef>
-          <a:effectRef idx="0">
-            <a:schemeClr val="accent1"/>
-          </a:effectRef>
-          <a:fontRef idx="minor">
-            <a:schemeClr val="lt1"/>
-          </a:fontRef>
-        </p:style>
-        <p:txBody>
-          <a:bodyPr rtlCol="0" anchor="ctr"/>
-          <a:lstStyle/>
-          <a:p>
-            <a:pPr algn="ctr"/>
-            <a:r>
-              <a:rPr lang="en-US" dirty="0">
-                <a:solidFill>
-                  <a:schemeClr val="tx1"/>
-                </a:solidFill>
-              </a:rPr>
-              <a:t>QH</a:t>
-            </a:r>
-          </a:p>
-        </p:txBody>
-      </p:sp>
-      <p:sp>
-        <p:nvSpPr>
-          <p:cNvPr id="13" name="TextBox 12">
-            <a:extLst>
-              <a:ext uri="{FF2B5EF4-FFF2-40B4-BE49-F238E27FC236}">
-                <a16:creationId xmlns:a16="http://schemas.microsoft.com/office/drawing/2014/main" id="{6A7A42A6-82F9-7496-A3C5-B06A31DEA920}"/>
-              </a:ext>
-            </a:extLst>
-          </p:cNvPr>
-          <p:cNvSpPr txBox="1"/>
-          <p:nvPr/>
-        </p:nvSpPr>
-        <p:spPr>
-          <a:xfrm>
-            <a:off x="6205694" y="2411168"/>
-            <a:ext cx="1073400" cy="276999"/>
-          </a:xfrm>
-          <a:prstGeom prst="rect">
-            <a:avLst/>
-          </a:prstGeom>
-          <a:noFill/>
-        </p:spPr>
-        <p:txBody>
-          <a:bodyPr wrap="square" rtlCol="0">
-            <a:spAutoFit/>
-          </a:bodyPr>
-          <a:lstStyle/>
-          <a:p>
-            <a:r>
-              <a:rPr lang="en-US" sz="1200" dirty="0">
-                <a:solidFill>
-                  <a:srgbClr val="FF0000"/>
-                </a:solidFill>
-              </a:rPr>
-              <a:t>Grid-3 (0,0)</a:t>
-            </a:r>
-          </a:p>
-        </p:txBody>
-      </p:sp>
-      <p:sp>
-        <p:nvSpPr>
-          <p:cNvPr id="20" name="TextBox 19">
-            <a:extLst>
-              <a:ext uri="{FF2B5EF4-FFF2-40B4-BE49-F238E27FC236}">
-                <a16:creationId xmlns:a16="http://schemas.microsoft.com/office/drawing/2014/main" id="{B112E086-9DCC-EEC5-F3B4-D4D5E645CBEE}"/>
-              </a:ext>
-            </a:extLst>
-          </p:cNvPr>
-          <p:cNvSpPr txBox="1"/>
-          <p:nvPr/>
-        </p:nvSpPr>
-        <p:spPr>
-          <a:xfrm>
-            <a:off x="11071611" y="2025517"/>
-            <a:ext cx="1073400" cy="276999"/>
-          </a:xfrm>
-          <a:prstGeom prst="rect">
-            <a:avLst/>
-          </a:prstGeom>
-          <a:noFill/>
-        </p:spPr>
-        <p:txBody>
-          <a:bodyPr wrap="square" rtlCol="0">
-            <a:spAutoFit/>
-          </a:bodyPr>
-          <a:lstStyle/>
-          <a:p>
-            <a:r>
-              <a:rPr lang="en-US" sz="1200" dirty="0">
-                <a:solidFill>
-                  <a:srgbClr val="FF0000"/>
-                </a:solidFill>
-              </a:rPr>
-              <a:t>Grid-2 (1,1-2)</a:t>
-            </a:r>
-          </a:p>
-        </p:txBody>
-      </p:sp>
-      <p:sp>
-        <p:nvSpPr>
-          <p:cNvPr id="23" name="Rectangle: Rounded Corners 22">
-            <a:extLst>
-              <a:ext uri="{FF2B5EF4-FFF2-40B4-BE49-F238E27FC236}">
-                <a16:creationId xmlns:a16="http://schemas.microsoft.com/office/drawing/2014/main" id="{E4E9AE66-D4AD-083D-3291-2E967F7FD9E7}"/>
-              </a:ext>
-            </a:extLst>
-          </p:cNvPr>
-          <p:cNvSpPr/>
-          <p:nvPr/>
-        </p:nvSpPr>
-        <p:spPr>
-          <a:xfrm>
-            <a:off x="6474575" y="502865"/>
-            <a:ext cx="891268" cy="1347825"/>
-          </a:xfrm>
-          <a:prstGeom prst="roundRect">
-            <a:avLst/>
-          </a:prstGeom>
-          <a:noFill/>
-        </p:spPr>
-        <p:style>
-          <a:lnRef idx="2">
-            <a:schemeClr val="accent1">
-              <a:shade val="15000"/>
-            </a:schemeClr>
-          </a:lnRef>
-          <a:fillRef idx="1">
-            <a:schemeClr val="accent1"/>
-          </a:fillRef>
-          <a:effectRef idx="0">
-            <a:schemeClr val="accent1"/>
-          </a:effectRef>
-          <a:fontRef idx="minor">
-            <a:schemeClr val="lt1"/>
-          </a:fontRef>
-        </p:style>
-        <p:txBody>
-          <a:bodyPr rtlCol="0" anchor="ctr"/>
-          <a:lstStyle/>
-          <a:p>
-            <a:pPr algn="ctr"/>
-            <a:r>
-              <a:rPr lang="en-US" dirty="0">
-                <a:solidFill>
-                  <a:schemeClr val="tx1"/>
-                </a:solidFill>
-              </a:rPr>
-              <a:t>9H</a:t>
-            </a:r>
-          </a:p>
-        </p:txBody>
-      </p:sp>
-      <p:sp>
-        <p:nvSpPr>
-          <p:cNvPr id="24" name="TextBox 23">
-            <a:extLst>
-              <a:ext uri="{FF2B5EF4-FFF2-40B4-BE49-F238E27FC236}">
-                <a16:creationId xmlns:a16="http://schemas.microsoft.com/office/drawing/2014/main" id="{DDDB0C11-AC15-B15B-8FAA-B44F6D106A0A}"/>
-              </a:ext>
-            </a:extLst>
-          </p:cNvPr>
-          <p:cNvSpPr txBox="1"/>
-          <p:nvPr/>
-        </p:nvSpPr>
-        <p:spPr>
-          <a:xfrm>
-            <a:off x="6474575" y="639674"/>
-            <a:ext cx="1073400" cy="276999"/>
-          </a:xfrm>
-          <a:prstGeom prst="rect">
-            <a:avLst/>
-          </a:prstGeom>
-          <a:noFill/>
-        </p:spPr>
-        <p:txBody>
-          <a:bodyPr wrap="square" rtlCol="0">
-            <a:spAutoFit/>
-          </a:bodyPr>
-          <a:lstStyle/>
-          <a:p>
-            <a:r>
-              <a:rPr lang="en-US" sz="1200" dirty="0">
-                <a:solidFill>
-                  <a:srgbClr val="FF0000"/>
-                </a:solidFill>
-              </a:rPr>
-              <a:t>Grid-3 (0,0)</a:t>
-            </a:r>
-          </a:p>
-        </p:txBody>
-      </p:sp>
-      <p:sp>
-        <p:nvSpPr>
-          <p:cNvPr id="26" name="Rectangle: Rounded Corners 25">
-            <a:extLst>
-              <a:ext uri="{FF2B5EF4-FFF2-40B4-BE49-F238E27FC236}">
-                <a16:creationId xmlns:a16="http://schemas.microsoft.com/office/drawing/2014/main" id="{EC832391-AB08-66D2-3ADB-ABCD6AE29211}"/>
-              </a:ext>
-            </a:extLst>
-          </p:cNvPr>
-          <p:cNvSpPr/>
-          <p:nvPr/>
-        </p:nvSpPr>
-        <p:spPr>
-          <a:xfrm>
-            <a:off x="8150157" y="2284680"/>
-            <a:ext cx="891268" cy="1347825"/>
-          </a:xfrm>
-          <a:prstGeom prst="roundRect">
-            <a:avLst/>
-          </a:prstGeom>
-          <a:noFill/>
-          <a:ln>
-            <a:prstDash val="sysDash"/>
-          </a:ln>
-        </p:spPr>
-        <p:style>
-          <a:lnRef idx="2">
-            <a:schemeClr val="accent1">
-              <a:shade val="15000"/>
-            </a:schemeClr>
-          </a:lnRef>
-          <a:fillRef idx="1">
-            <a:schemeClr val="accent1"/>
-          </a:fillRef>
-          <a:effectRef idx="0">
-            <a:schemeClr val="accent1"/>
-          </a:effectRef>
-          <a:fontRef idx="minor">
-            <a:schemeClr val="lt1"/>
-          </a:fontRef>
-        </p:style>
-        <p:txBody>
-          <a:bodyPr rtlCol="0" anchor="ctr"/>
-          <a:lstStyle/>
-          <a:p>
-            <a:pPr algn="ctr"/>
-            <a:endParaRPr lang="en-US" dirty="0">
-              <a:solidFill>
-                <a:schemeClr val="tx1"/>
-              </a:solidFill>
-            </a:endParaRPr>
-          </a:p>
-        </p:txBody>
-      </p:sp>
-      <p:sp>
-        <p:nvSpPr>
-          <p:cNvPr id="27" name="TextBox 26">
-            <a:extLst>
-              <a:ext uri="{FF2B5EF4-FFF2-40B4-BE49-F238E27FC236}">
-                <a16:creationId xmlns:a16="http://schemas.microsoft.com/office/drawing/2014/main" id="{C7E76ECA-6402-3293-B515-31A09A9F9B30}"/>
-              </a:ext>
-            </a:extLst>
-          </p:cNvPr>
-          <p:cNvSpPr txBox="1"/>
-          <p:nvPr/>
-        </p:nvSpPr>
-        <p:spPr>
-          <a:xfrm>
-            <a:off x="8150157" y="2363506"/>
-            <a:ext cx="1073400" cy="276999"/>
-          </a:xfrm>
-          <a:prstGeom prst="rect">
-            <a:avLst/>
-          </a:prstGeom>
-          <a:noFill/>
-        </p:spPr>
-        <p:txBody>
-          <a:bodyPr wrap="square" rtlCol="0">
-            <a:spAutoFit/>
-          </a:bodyPr>
-          <a:lstStyle/>
-          <a:p>
-            <a:r>
-              <a:rPr lang="en-US" sz="1200" dirty="0">
-                <a:solidFill>
-                  <a:srgbClr val="FF0000"/>
-                </a:solidFill>
-              </a:rPr>
-              <a:t>Grid-3 (0,2)</a:t>
-            </a:r>
-          </a:p>
-        </p:txBody>
-      </p:sp>
-      <p:sp>
-        <p:nvSpPr>
-          <p:cNvPr id="29" name="Rectangle: Rounded Corners 28">
-            <a:extLst>
-              <a:ext uri="{FF2B5EF4-FFF2-40B4-BE49-F238E27FC236}">
-                <a16:creationId xmlns:a16="http://schemas.microsoft.com/office/drawing/2014/main" id="{BFC6CD2E-C0C2-7824-806D-08C14C9BE2B0}"/>
-              </a:ext>
-            </a:extLst>
-          </p:cNvPr>
-          <p:cNvSpPr/>
-          <p:nvPr/>
-        </p:nvSpPr>
-        <p:spPr>
-          <a:xfrm>
-            <a:off x="7178956" y="2297233"/>
-            <a:ext cx="891268" cy="1347825"/>
-          </a:xfrm>
-          <a:prstGeom prst="roundRect">
-            <a:avLst/>
-          </a:prstGeom>
-          <a:noFill/>
-        </p:spPr>
-        <p:style>
-          <a:lnRef idx="2">
-            <a:schemeClr val="accent1">
-              <a:shade val="15000"/>
-            </a:schemeClr>
-          </a:lnRef>
-          <a:fillRef idx="1">
-            <a:schemeClr val="accent1"/>
-          </a:fillRef>
-          <a:effectRef idx="0">
-            <a:schemeClr val="accent1"/>
-          </a:effectRef>
-          <a:fontRef idx="minor">
-            <a:schemeClr val="lt1"/>
-          </a:fontRef>
-        </p:style>
-        <p:txBody>
-          <a:bodyPr rtlCol="0" anchor="ctr"/>
-          <a:lstStyle/>
-          <a:p>
-            <a:pPr algn="ctr"/>
-            <a:r>
-              <a:rPr lang="en-US" dirty="0">
-                <a:solidFill>
-                  <a:schemeClr val="tx1"/>
-                </a:solidFill>
-              </a:rPr>
-              <a:t>6C</a:t>
-            </a:r>
-          </a:p>
-        </p:txBody>
-      </p:sp>
-      <p:sp>
-        <p:nvSpPr>
-          <p:cNvPr id="30" name="TextBox 29">
-            <a:extLst>
-              <a:ext uri="{FF2B5EF4-FFF2-40B4-BE49-F238E27FC236}">
-                <a16:creationId xmlns:a16="http://schemas.microsoft.com/office/drawing/2014/main" id="{7C5DC42A-F061-F5D0-E2FD-57A4696CDE19}"/>
-              </a:ext>
-            </a:extLst>
-          </p:cNvPr>
-          <p:cNvSpPr txBox="1"/>
-          <p:nvPr/>
-        </p:nvSpPr>
-        <p:spPr>
-          <a:xfrm>
-            <a:off x="7178956" y="2434042"/>
-            <a:ext cx="1073400" cy="276999"/>
-          </a:xfrm>
-          <a:prstGeom prst="rect">
-            <a:avLst/>
-          </a:prstGeom>
-          <a:noFill/>
-        </p:spPr>
-        <p:txBody>
-          <a:bodyPr wrap="square" rtlCol="0">
-            <a:spAutoFit/>
-          </a:bodyPr>
-          <a:lstStyle/>
-          <a:p>
-            <a:r>
-              <a:rPr lang="en-US" sz="1200" dirty="0">
-                <a:solidFill>
-                  <a:srgbClr val="FF0000"/>
-                </a:solidFill>
-              </a:rPr>
-              <a:t>Grid-3 (0,1)</a:t>
-            </a:r>
-          </a:p>
-        </p:txBody>
-      </p:sp>
-      <p:sp>
-        <p:nvSpPr>
-          <p:cNvPr id="32" name="Rectangle: Rounded Corners 31">
-            <a:extLst>
-              <a:ext uri="{FF2B5EF4-FFF2-40B4-BE49-F238E27FC236}">
-                <a16:creationId xmlns:a16="http://schemas.microsoft.com/office/drawing/2014/main" id="{22B87102-D410-9D40-A1E2-357F9C24D0AF}"/>
-              </a:ext>
-            </a:extLst>
-          </p:cNvPr>
-          <p:cNvSpPr/>
-          <p:nvPr/>
-        </p:nvSpPr>
-        <p:spPr>
-          <a:xfrm>
-            <a:off x="9086827" y="2280371"/>
-            <a:ext cx="891268" cy="1347825"/>
-          </a:xfrm>
-          <a:prstGeom prst="roundRect">
-            <a:avLst/>
-          </a:prstGeom>
-          <a:noFill/>
-          <a:ln>
-            <a:prstDash val="sysDash"/>
-          </a:ln>
-        </p:spPr>
-        <p:style>
-          <a:lnRef idx="2">
-            <a:schemeClr val="accent1">
-              <a:shade val="15000"/>
-            </a:schemeClr>
-          </a:lnRef>
-          <a:fillRef idx="1">
-            <a:schemeClr val="accent1"/>
-          </a:fillRef>
-          <a:effectRef idx="0">
-            <a:schemeClr val="accent1"/>
-          </a:effectRef>
-          <a:fontRef idx="minor">
-            <a:schemeClr val="lt1"/>
-          </a:fontRef>
-        </p:style>
-        <p:txBody>
-          <a:bodyPr rtlCol="0" anchor="ctr"/>
-          <a:lstStyle/>
-          <a:p>
-            <a:pPr algn="ctr"/>
-            <a:endParaRPr lang="en-US" dirty="0">
-              <a:solidFill>
-                <a:schemeClr val="tx1"/>
-              </a:solidFill>
-            </a:endParaRPr>
-          </a:p>
-        </p:txBody>
-      </p:sp>
-      <p:sp>
-        <p:nvSpPr>
-          <p:cNvPr id="33" name="TextBox 32">
-            <a:extLst>
-              <a:ext uri="{FF2B5EF4-FFF2-40B4-BE49-F238E27FC236}">
-                <a16:creationId xmlns:a16="http://schemas.microsoft.com/office/drawing/2014/main" id="{27BDDAB9-1161-A47F-AE0B-B16AFE581A0D}"/>
-              </a:ext>
-            </a:extLst>
-          </p:cNvPr>
-          <p:cNvSpPr txBox="1"/>
-          <p:nvPr/>
-        </p:nvSpPr>
-        <p:spPr>
-          <a:xfrm>
-            <a:off x="9072583" y="2324664"/>
-            <a:ext cx="1073400" cy="276999"/>
-          </a:xfrm>
-          <a:prstGeom prst="rect">
-            <a:avLst/>
-          </a:prstGeom>
-          <a:noFill/>
-        </p:spPr>
-        <p:txBody>
-          <a:bodyPr wrap="square" rtlCol="0">
-            <a:spAutoFit/>
-          </a:bodyPr>
-          <a:lstStyle/>
-          <a:p>
-            <a:r>
-              <a:rPr lang="en-US" sz="1200" dirty="0">
-                <a:solidFill>
-                  <a:srgbClr val="FF0000"/>
-                </a:solidFill>
-              </a:rPr>
-              <a:t>Grid-3 (0,3)</a:t>
-            </a:r>
-          </a:p>
-        </p:txBody>
-      </p:sp>
-      <p:sp>
-        <p:nvSpPr>
-          <p:cNvPr id="35" name="Rectangle: Rounded Corners 34">
-            <a:extLst>
-              <a:ext uri="{FF2B5EF4-FFF2-40B4-BE49-F238E27FC236}">
-                <a16:creationId xmlns:a16="http://schemas.microsoft.com/office/drawing/2014/main" id="{1204C15B-4BA5-EE63-68F5-16E4D9B5AA5B}"/>
-              </a:ext>
-            </a:extLst>
-          </p:cNvPr>
-          <p:cNvSpPr/>
-          <p:nvPr/>
-        </p:nvSpPr>
-        <p:spPr>
-          <a:xfrm>
-            <a:off x="8072123" y="394212"/>
-            <a:ext cx="891268" cy="1347825"/>
-          </a:xfrm>
-          <a:prstGeom prst="roundRect">
-            <a:avLst/>
-          </a:prstGeom>
-          <a:noFill/>
-        </p:spPr>
-        <p:style>
-          <a:lnRef idx="2">
-            <a:schemeClr val="accent1">
-              <a:shade val="15000"/>
-            </a:schemeClr>
-          </a:lnRef>
-          <a:fillRef idx="1">
-            <a:schemeClr val="accent1"/>
-          </a:fillRef>
-          <a:effectRef idx="0">
-            <a:schemeClr val="accent1"/>
-          </a:effectRef>
-          <a:fontRef idx="minor">
-            <a:schemeClr val="lt1"/>
-          </a:fontRef>
-        </p:style>
-        <p:txBody>
-          <a:bodyPr rtlCol="0" anchor="ctr"/>
-          <a:lstStyle/>
-          <a:p>
-            <a:pPr algn="ctr"/>
-            <a:endParaRPr lang="en-US" dirty="0">
-              <a:solidFill>
-                <a:schemeClr val="tx1"/>
-              </a:solidFill>
-            </a:endParaRPr>
-          </a:p>
-        </p:txBody>
-      </p:sp>
-      <p:sp>
-        <p:nvSpPr>
-          <p:cNvPr id="36" name="TextBox 35">
-            <a:extLst>
-              <a:ext uri="{FF2B5EF4-FFF2-40B4-BE49-F238E27FC236}">
-                <a16:creationId xmlns:a16="http://schemas.microsoft.com/office/drawing/2014/main" id="{0B38137C-90F2-3D06-0E18-11870C0F11B5}"/>
-              </a:ext>
-            </a:extLst>
-          </p:cNvPr>
-          <p:cNvSpPr txBox="1"/>
-          <p:nvPr/>
-        </p:nvSpPr>
-        <p:spPr>
-          <a:xfrm>
-            <a:off x="8072123" y="531021"/>
-            <a:ext cx="1073400" cy="276999"/>
-          </a:xfrm>
-          <a:prstGeom prst="rect">
-            <a:avLst/>
-          </a:prstGeom>
-          <a:noFill/>
-        </p:spPr>
-        <p:txBody>
-          <a:bodyPr wrap="square" rtlCol="0">
-            <a:spAutoFit/>
-          </a:bodyPr>
-          <a:lstStyle/>
-          <a:p>
-            <a:r>
-              <a:rPr lang="en-US" sz="1200" dirty="0">
-                <a:solidFill>
-                  <a:srgbClr val="FF0000"/>
-                </a:solidFill>
-              </a:rPr>
-              <a:t>Grid-3 (0,0)</a:t>
-            </a:r>
-          </a:p>
-        </p:txBody>
-      </p:sp>
-      <p:sp>
-        <p:nvSpPr>
-          <p:cNvPr id="38" name="Rectangle: Rounded Corners 37">
-            <a:extLst>
-              <a:ext uri="{FF2B5EF4-FFF2-40B4-BE49-F238E27FC236}">
-                <a16:creationId xmlns:a16="http://schemas.microsoft.com/office/drawing/2014/main" id="{CE2CBAF2-D2BA-9475-F44A-0C96525D9AB4}"/>
-              </a:ext>
-            </a:extLst>
-          </p:cNvPr>
-          <p:cNvSpPr/>
-          <p:nvPr/>
-        </p:nvSpPr>
-        <p:spPr>
-          <a:xfrm>
-            <a:off x="10009341" y="419000"/>
-            <a:ext cx="891268" cy="1347825"/>
-          </a:xfrm>
-          <a:prstGeom prst="roundRect">
-            <a:avLst/>
-          </a:prstGeom>
-          <a:noFill/>
-        </p:spPr>
-        <p:style>
-          <a:lnRef idx="2">
-            <a:schemeClr val="accent1">
-              <a:shade val="15000"/>
-            </a:schemeClr>
-          </a:lnRef>
-          <a:fillRef idx="1">
-            <a:schemeClr val="accent1"/>
-          </a:fillRef>
-          <a:effectRef idx="0">
-            <a:schemeClr val="accent1"/>
-          </a:effectRef>
-          <a:fontRef idx="minor">
-            <a:schemeClr val="lt1"/>
-          </a:fontRef>
-        </p:style>
-        <p:txBody>
-          <a:bodyPr rtlCol="0" anchor="ctr"/>
-          <a:lstStyle/>
-          <a:p>
-            <a:pPr algn="ctr"/>
-            <a:endParaRPr lang="en-US" dirty="0">
-              <a:solidFill>
-                <a:schemeClr val="tx1"/>
-              </a:solidFill>
-            </a:endParaRPr>
-          </a:p>
-        </p:txBody>
-      </p:sp>
-      <p:sp>
-        <p:nvSpPr>
-          <p:cNvPr id="39" name="TextBox 38">
-            <a:extLst>
-              <a:ext uri="{FF2B5EF4-FFF2-40B4-BE49-F238E27FC236}">
-                <a16:creationId xmlns:a16="http://schemas.microsoft.com/office/drawing/2014/main" id="{B27F5665-A831-3A6E-E8C5-1D9E1059F849}"/>
-              </a:ext>
-            </a:extLst>
-          </p:cNvPr>
-          <p:cNvSpPr txBox="1"/>
-          <p:nvPr/>
-        </p:nvSpPr>
-        <p:spPr>
-          <a:xfrm>
-            <a:off x="10009341" y="555809"/>
-            <a:ext cx="1073400" cy="276999"/>
-          </a:xfrm>
-          <a:prstGeom prst="rect">
-            <a:avLst/>
-          </a:prstGeom>
-          <a:noFill/>
-        </p:spPr>
-        <p:txBody>
-          <a:bodyPr wrap="square" rtlCol="0">
-            <a:spAutoFit/>
-          </a:bodyPr>
-          <a:lstStyle/>
-          <a:p>
-            <a:r>
-              <a:rPr lang="en-US" sz="1200" dirty="0">
-                <a:solidFill>
-                  <a:srgbClr val="FF0000"/>
-                </a:solidFill>
-              </a:rPr>
-              <a:t>Grid-3 (0,2)</a:t>
-            </a:r>
-          </a:p>
-        </p:txBody>
-      </p:sp>
-      <p:sp>
-        <p:nvSpPr>
-          <p:cNvPr id="41" name="Rectangle: Rounded Corners 40">
-            <a:extLst>
-              <a:ext uri="{FF2B5EF4-FFF2-40B4-BE49-F238E27FC236}">
-                <a16:creationId xmlns:a16="http://schemas.microsoft.com/office/drawing/2014/main" id="{71151ECE-8B45-6A20-D4CD-7C25F2FE1520}"/>
-              </a:ext>
-            </a:extLst>
-          </p:cNvPr>
-          <p:cNvSpPr/>
-          <p:nvPr/>
-        </p:nvSpPr>
-        <p:spPr>
-          <a:xfrm>
-            <a:off x="9021473" y="421177"/>
-            <a:ext cx="891268" cy="1347825"/>
-          </a:xfrm>
-          <a:prstGeom prst="roundRect">
-            <a:avLst/>
-          </a:prstGeom>
-          <a:noFill/>
-        </p:spPr>
-        <p:style>
-          <a:lnRef idx="2">
-            <a:schemeClr val="accent1">
-              <a:shade val="15000"/>
-            </a:schemeClr>
-          </a:lnRef>
-          <a:fillRef idx="1">
-            <a:schemeClr val="accent1"/>
-          </a:fillRef>
-          <a:effectRef idx="0">
-            <a:schemeClr val="accent1"/>
-          </a:effectRef>
-          <a:fontRef idx="minor">
-            <a:schemeClr val="lt1"/>
-          </a:fontRef>
-        </p:style>
-        <p:txBody>
-          <a:bodyPr rtlCol="0" anchor="ctr"/>
-          <a:lstStyle/>
-          <a:p>
-            <a:pPr algn="ctr"/>
-            <a:endParaRPr lang="en-US" dirty="0">
-              <a:solidFill>
-                <a:schemeClr val="tx1"/>
-              </a:solidFill>
-            </a:endParaRPr>
-          </a:p>
-        </p:txBody>
-      </p:sp>
-      <p:sp>
-        <p:nvSpPr>
-          <p:cNvPr id="42" name="TextBox 41">
-            <a:extLst>
-              <a:ext uri="{FF2B5EF4-FFF2-40B4-BE49-F238E27FC236}">
-                <a16:creationId xmlns:a16="http://schemas.microsoft.com/office/drawing/2014/main" id="{1BA2C7B6-682A-4E3E-D1CE-D838D077562F}"/>
-              </a:ext>
-            </a:extLst>
-          </p:cNvPr>
-          <p:cNvSpPr txBox="1"/>
-          <p:nvPr/>
-        </p:nvSpPr>
-        <p:spPr>
-          <a:xfrm>
-            <a:off x="9021473" y="557986"/>
-            <a:ext cx="1073400" cy="276999"/>
-          </a:xfrm>
-          <a:prstGeom prst="rect">
-            <a:avLst/>
-          </a:prstGeom>
-          <a:noFill/>
-        </p:spPr>
-        <p:txBody>
-          <a:bodyPr wrap="square" rtlCol="0">
-            <a:spAutoFit/>
-          </a:bodyPr>
-          <a:lstStyle/>
-          <a:p>
-            <a:r>
-              <a:rPr lang="en-US" sz="1200" dirty="0">
-                <a:solidFill>
-                  <a:srgbClr val="FF0000"/>
-                </a:solidFill>
-              </a:rPr>
-              <a:t>Grid-3 (0,1)</a:t>
-            </a:r>
-          </a:p>
-        </p:txBody>
-      </p:sp>
-      <p:sp>
-        <p:nvSpPr>
-          <p:cNvPr id="44" name="Rectangle: Rounded Corners 43">
-            <a:extLst>
-              <a:ext uri="{FF2B5EF4-FFF2-40B4-BE49-F238E27FC236}">
-                <a16:creationId xmlns:a16="http://schemas.microsoft.com/office/drawing/2014/main" id="{E686572F-6F08-2389-4A3D-FD6EC3F964A4}"/>
-              </a:ext>
-            </a:extLst>
-          </p:cNvPr>
-          <p:cNvSpPr/>
-          <p:nvPr/>
-        </p:nvSpPr>
-        <p:spPr>
-          <a:xfrm>
-            <a:off x="10958691" y="411184"/>
-            <a:ext cx="891268" cy="1347825"/>
-          </a:xfrm>
-          <a:prstGeom prst="roundRect">
-            <a:avLst/>
-          </a:prstGeom>
-          <a:noFill/>
-        </p:spPr>
-        <p:style>
-          <a:lnRef idx="2">
-            <a:schemeClr val="accent1">
-              <a:shade val="15000"/>
-            </a:schemeClr>
-          </a:lnRef>
-          <a:fillRef idx="1">
-            <a:schemeClr val="accent1"/>
-          </a:fillRef>
-          <a:effectRef idx="0">
-            <a:schemeClr val="accent1"/>
-          </a:effectRef>
-          <a:fontRef idx="minor">
-            <a:schemeClr val="lt1"/>
-          </a:fontRef>
-        </p:style>
-        <p:txBody>
-          <a:bodyPr rtlCol="0" anchor="ctr"/>
-          <a:lstStyle/>
-          <a:p>
-            <a:pPr algn="ctr"/>
-            <a:endParaRPr lang="en-US" dirty="0">
-              <a:solidFill>
-                <a:schemeClr val="tx1"/>
-              </a:solidFill>
-            </a:endParaRPr>
-          </a:p>
-        </p:txBody>
-      </p:sp>
-      <p:sp>
-        <p:nvSpPr>
-          <p:cNvPr id="45" name="TextBox 44">
-            <a:extLst>
-              <a:ext uri="{FF2B5EF4-FFF2-40B4-BE49-F238E27FC236}">
-                <a16:creationId xmlns:a16="http://schemas.microsoft.com/office/drawing/2014/main" id="{D28F6FAC-8153-408B-CBE1-D545BEDF0A5E}"/>
-              </a:ext>
-            </a:extLst>
-          </p:cNvPr>
-          <p:cNvSpPr txBox="1"/>
-          <p:nvPr/>
-        </p:nvSpPr>
-        <p:spPr>
-          <a:xfrm>
-            <a:off x="10958691" y="547993"/>
-            <a:ext cx="1073400" cy="276999"/>
-          </a:xfrm>
-          <a:prstGeom prst="rect">
-            <a:avLst/>
-          </a:prstGeom>
-          <a:noFill/>
-        </p:spPr>
-        <p:txBody>
-          <a:bodyPr wrap="square" rtlCol="0">
-            <a:spAutoFit/>
-          </a:bodyPr>
-          <a:lstStyle/>
-          <a:p>
-            <a:r>
-              <a:rPr lang="en-US" sz="1200" dirty="0">
-                <a:solidFill>
-                  <a:srgbClr val="FF0000"/>
-                </a:solidFill>
-              </a:rPr>
-              <a:t>Grid-3 (0,3)</a:t>
-            </a:r>
-          </a:p>
-        </p:txBody>
-      </p:sp>
-      <p:sp>
-        <p:nvSpPr>
-          <p:cNvPr id="47" name="Rectangle: Rounded Corners 46">
-            <a:extLst>
-              <a:ext uri="{FF2B5EF4-FFF2-40B4-BE49-F238E27FC236}">
-                <a16:creationId xmlns:a16="http://schemas.microsoft.com/office/drawing/2014/main" id="{8A9051EA-F7FC-5822-1A07-0178B4893C79}"/>
-              </a:ext>
-            </a:extLst>
-          </p:cNvPr>
-          <p:cNvSpPr/>
-          <p:nvPr/>
-        </p:nvSpPr>
-        <p:spPr>
-          <a:xfrm>
-            <a:off x="6070502" y="3893261"/>
-            <a:ext cx="891268" cy="1347825"/>
-          </a:xfrm>
-          <a:prstGeom prst="roundRect">
-            <a:avLst/>
-          </a:prstGeom>
-          <a:noFill/>
-        </p:spPr>
-        <p:style>
-          <a:lnRef idx="2">
-            <a:schemeClr val="accent1">
-              <a:shade val="15000"/>
-            </a:schemeClr>
-          </a:lnRef>
-          <a:fillRef idx="1">
-            <a:schemeClr val="accent1"/>
-          </a:fillRef>
-          <a:effectRef idx="0">
-            <a:schemeClr val="accent1"/>
-          </a:effectRef>
-          <a:fontRef idx="minor">
-            <a:schemeClr val="lt1"/>
-          </a:fontRef>
-        </p:style>
-        <p:txBody>
-          <a:bodyPr rtlCol="0" anchor="ctr"/>
-          <a:lstStyle/>
-          <a:p>
-            <a:pPr algn="ctr"/>
-            <a:r>
-              <a:rPr lang="en-US" dirty="0">
-                <a:solidFill>
-                  <a:schemeClr val="tx1"/>
-                </a:solidFill>
-              </a:rPr>
-              <a:t>KH</a:t>
-            </a:r>
-          </a:p>
-        </p:txBody>
-      </p:sp>
-      <p:sp>
-        <p:nvSpPr>
-          <p:cNvPr id="48" name="TextBox 47">
-            <a:extLst>
-              <a:ext uri="{FF2B5EF4-FFF2-40B4-BE49-F238E27FC236}">
-                <a16:creationId xmlns:a16="http://schemas.microsoft.com/office/drawing/2014/main" id="{D223CACA-90B8-93FA-7C06-E59994F0681B}"/>
-              </a:ext>
-            </a:extLst>
-          </p:cNvPr>
-          <p:cNvSpPr txBox="1"/>
-          <p:nvPr/>
-        </p:nvSpPr>
-        <p:spPr>
-          <a:xfrm>
-            <a:off x="6053452" y="3935811"/>
-            <a:ext cx="1073400" cy="276999"/>
-          </a:xfrm>
-          <a:prstGeom prst="rect">
-            <a:avLst/>
-          </a:prstGeom>
-          <a:noFill/>
-        </p:spPr>
-        <p:txBody>
-          <a:bodyPr wrap="square" rtlCol="0">
-            <a:spAutoFit/>
-          </a:bodyPr>
-          <a:lstStyle/>
-          <a:p>
-            <a:r>
-              <a:rPr lang="en-US" sz="1200" dirty="0">
-                <a:solidFill>
-                  <a:srgbClr val="FF0000"/>
-                </a:solidFill>
-              </a:rPr>
-              <a:t>Grid-3 (0,0)</a:t>
-            </a:r>
-          </a:p>
-        </p:txBody>
-      </p:sp>
-      <p:sp>
-        <p:nvSpPr>
-          <p:cNvPr id="49" name="TextBox 48">
-            <a:extLst>
-              <a:ext uri="{FF2B5EF4-FFF2-40B4-BE49-F238E27FC236}">
-                <a16:creationId xmlns:a16="http://schemas.microsoft.com/office/drawing/2014/main" id="{925529E7-B3DC-B8AE-7DB6-A1FFF6BEBBBE}"/>
-              </a:ext>
-            </a:extLst>
-          </p:cNvPr>
-          <p:cNvSpPr txBox="1"/>
-          <p:nvPr/>
-        </p:nvSpPr>
-        <p:spPr>
-          <a:xfrm>
-            <a:off x="7453838" y="3658942"/>
-            <a:ext cx="1073400" cy="276999"/>
-          </a:xfrm>
-          <a:prstGeom prst="rect">
-            <a:avLst/>
-          </a:prstGeom>
-          <a:noFill/>
-        </p:spPr>
-        <p:txBody>
-          <a:bodyPr wrap="square" rtlCol="0">
-            <a:spAutoFit/>
-          </a:bodyPr>
-          <a:lstStyle/>
-          <a:p>
-            <a:r>
-              <a:rPr lang="en-US" sz="1200" dirty="0">
-                <a:solidFill>
-                  <a:srgbClr val="FF0000"/>
-                </a:solidFill>
-              </a:rPr>
-              <a:t>Grid-2 (2,1-2)</a:t>
-            </a:r>
-          </a:p>
-        </p:txBody>
-      </p:sp>
-      <p:sp>
-        <p:nvSpPr>
-          <p:cNvPr id="50" name="TextBox 49">
-            <a:extLst>
-              <a:ext uri="{FF2B5EF4-FFF2-40B4-BE49-F238E27FC236}">
-                <a16:creationId xmlns:a16="http://schemas.microsoft.com/office/drawing/2014/main" id="{F9637D72-AA88-04DB-22C4-DC1C45AAFCAE}"/>
-              </a:ext>
-            </a:extLst>
-          </p:cNvPr>
-          <p:cNvSpPr txBox="1"/>
-          <p:nvPr/>
-        </p:nvSpPr>
-        <p:spPr>
-          <a:xfrm>
-            <a:off x="10958691" y="148339"/>
-            <a:ext cx="1073400" cy="276999"/>
-          </a:xfrm>
-          <a:prstGeom prst="rect">
-            <a:avLst/>
-          </a:prstGeom>
-          <a:noFill/>
-        </p:spPr>
-        <p:txBody>
-          <a:bodyPr wrap="square" rtlCol="0">
-            <a:spAutoFit/>
-          </a:bodyPr>
-          <a:lstStyle/>
-          <a:p>
-            <a:r>
-              <a:rPr lang="en-US" sz="1200" dirty="0">
-                <a:solidFill>
-                  <a:srgbClr val="FF0000"/>
-                </a:solidFill>
-              </a:rPr>
-              <a:t>Grid-2 (0,2)</a:t>
-            </a:r>
-          </a:p>
-        </p:txBody>
-      </p:sp>
-      <p:sp>
-        <p:nvSpPr>
-          <p:cNvPr id="52" name="Rectangle: Rounded Corners 51">
-            <a:extLst>
-              <a:ext uri="{FF2B5EF4-FFF2-40B4-BE49-F238E27FC236}">
-                <a16:creationId xmlns:a16="http://schemas.microsoft.com/office/drawing/2014/main" id="{B03325E8-23D3-621B-D9E3-228CEB9EFFFF}"/>
-              </a:ext>
-            </a:extLst>
-          </p:cNvPr>
-          <p:cNvSpPr/>
-          <p:nvPr/>
-        </p:nvSpPr>
-        <p:spPr>
-          <a:xfrm>
-            <a:off x="6978820" y="3903254"/>
-            <a:ext cx="891268" cy="1347825"/>
-          </a:xfrm>
-          <a:prstGeom prst="roundRect">
-            <a:avLst/>
-          </a:prstGeom>
-          <a:noFill/>
-        </p:spPr>
-        <p:style>
-          <a:lnRef idx="2">
-            <a:schemeClr val="accent1">
-              <a:shade val="15000"/>
-            </a:schemeClr>
-          </a:lnRef>
-          <a:fillRef idx="1">
-            <a:schemeClr val="accent1"/>
-          </a:fillRef>
-          <a:effectRef idx="0">
-            <a:schemeClr val="accent1"/>
-          </a:effectRef>
-          <a:fontRef idx="minor">
-            <a:schemeClr val="lt1"/>
-          </a:fontRef>
-        </p:style>
-        <p:txBody>
-          <a:bodyPr rtlCol="0" anchor="ctr"/>
-          <a:lstStyle/>
-          <a:p>
-            <a:pPr algn="ctr"/>
-            <a:r>
-              <a:rPr lang="en-US" dirty="0">
-                <a:solidFill>
-                  <a:schemeClr val="tx1"/>
-                </a:solidFill>
-              </a:rPr>
-              <a:t>5S</a:t>
-            </a:r>
-          </a:p>
-        </p:txBody>
-      </p:sp>
-      <p:sp>
-        <p:nvSpPr>
-          <p:cNvPr id="53" name="TextBox 52">
-            <a:extLst>
-              <a:ext uri="{FF2B5EF4-FFF2-40B4-BE49-F238E27FC236}">
-                <a16:creationId xmlns:a16="http://schemas.microsoft.com/office/drawing/2014/main" id="{5BFBDA40-4CBD-675D-18CE-395BB99F92C1}"/>
-              </a:ext>
-            </a:extLst>
-          </p:cNvPr>
-          <p:cNvSpPr txBox="1"/>
-          <p:nvPr/>
-        </p:nvSpPr>
-        <p:spPr>
-          <a:xfrm>
-            <a:off x="6995615" y="3926882"/>
-            <a:ext cx="1073400" cy="276999"/>
-          </a:xfrm>
-          <a:prstGeom prst="rect">
-            <a:avLst/>
-          </a:prstGeom>
-          <a:noFill/>
-        </p:spPr>
-        <p:txBody>
-          <a:bodyPr wrap="square" rtlCol="0">
-            <a:spAutoFit/>
-          </a:bodyPr>
-          <a:lstStyle/>
-          <a:p>
-            <a:r>
-              <a:rPr lang="en-US" sz="1200" dirty="0">
-                <a:solidFill>
-                  <a:srgbClr val="FF0000"/>
-                </a:solidFill>
-              </a:rPr>
-              <a:t>Grid-3 (0,1)</a:t>
-            </a:r>
-          </a:p>
-        </p:txBody>
-      </p:sp>
-      <p:sp>
-        <p:nvSpPr>
-          <p:cNvPr id="55" name="Rectangle: Rounded Corners 54">
-            <a:extLst>
-              <a:ext uri="{FF2B5EF4-FFF2-40B4-BE49-F238E27FC236}">
-                <a16:creationId xmlns:a16="http://schemas.microsoft.com/office/drawing/2014/main" id="{57091689-FF3E-0FCD-F23F-5FAE19E71A60}"/>
-              </a:ext>
-            </a:extLst>
-          </p:cNvPr>
-          <p:cNvSpPr/>
-          <p:nvPr/>
-        </p:nvSpPr>
-        <p:spPr>
-          <a:xfrm>
-            <a:off x="7881015" y="3903254"/>
-            <a:ext cx="891268" cy="1347825"/>
-          </a:xfrm>
-          <a:prstGeom prst="roundRect">
-            <a:avLst/>
-          </a:prstGeom>
-          <a:noFill/>
-        </p:spPr>
-        <p:style>
-          <a:lnRef idx="2">
-            <a:schemeClr val="accent1">
-              <a:shade val="15000"/>
-            </a:schemeClr>
-          </a:lnRef>
-          <a:fillRef idx="1">
-            <a:schemeClr val="accent1"/>
-          </a:fillRef>
-          <a:effectRef idx="0">
-            <a:schemeClr val="accent1"/>
-          </a:effectRef>
-          <a:fontRef idx="minor">
-            <a:schemeClr val="lt1"/>
-          </a:fontRef>
-        </p:style>
-        <p:txBody>
-          <a:bodyPr rtlCol="0" anchor="ctr"/>
-          <a:lstStyle/>
-          <a:p>
-            <a:pPr algn="ctr"/>
-            <a:r>
-              <a:rPr lang="en-US" dirty="0">
-                <a:solidFill>
-                  <a:schemeClr val="tx1"/>
-                </a:solidFill>
-              </a:rPr>
-              <a:t>5D</a:t>
-            </a:r>
-          </a:p>
-        </p:txBody>
-      </p:sp>
-      <p:sp>
-        <p:nvSpPr>
-          <p:cNvPr id="56" name="TextBox 55">
-            <a:extLst>
-              <a:ext uri="{FF2B5EF4-FFF2-40B4-BE49-F238E27FC236}">
-                <a16:creationId xmlns:a16="http://schemas.microsoft.com/office/drawing/2014/main" id="{066DE519-D912-9A33-5E33-1A5705CBAC36}"/>
-              </a:ext>
-            </a:extLst>
-          </p:cNvPr>
-          <p:cNvSpPr txBox="1"/>
-          <p:nvPr/>
-        </p:nvSpPr>
-        <p:spPr>
-          <a:xfrm>
-            <a:off x="7899694" y="3902203"/>
-            <a:ext cx="1073400" cy="276999"/>
-          </a:xfrm>
-          <a:prstGeom prst="rect">
-            <a:avLst/>
-          </a:prstGeom>
-          <a:noFill/>
-        </p:spPr>
-        <p:txBody>
-          <a:bodyPr wrap="square" rtlCol="0">
-            <a:spAutoFit/>
-          </a:bodyPr>
-          <a:lstStyle/>
-          <a:p>
-            <a:r>
-              <a:rPr lang="en-US" sz="1200" dirty="0">
-                <a:solidFill>
-                  <a:srgbClr val="FF0000"/>
-                </a:solidFill>
-              </a:rPr>
-              <a:t>Grid-3 (0,2)</a:t>
-            </a:r>
-          </a:p>
-        </p:txBody>
-      </p:sp>
-      <p:sp>
-        <p:nvSpPr>
-          <p:cNvPr id="58" name="Rectangle: Rounded Corners 57">
-            <a:extLst>
-              <a:ext uri="{FF2B5EF4-FFF2-40B4-BE49-F238E27FC236}">
-                <a16:creationId xmlns:a16="http://schemas.microsoft.com/office/drawing/2014/main" id="{E4691C00-FB3C-5285-3DBA-F175B73E744E}"/>
-              </a:ext>
-            </a:extLst>
-          </p:cNvPr>
-          <p:cNvSpPr/>
-          <p:nvPr/>
-        </p:nvSpPr>
-        <p:spPr>
-          <a:xfrm>
-            <a:off x="8784688" y="3926882"/>
-            <a:ext cx="891268" cy="1347825"/>
-          </a:xfrm>
-          <a:prstGeom prst="roundRect">
-            <a:avLst/>
-          </a:prstGeom>
-          <a:noFill/>
-          <a:ln>
-            <a:prstDash val="sysDash"/>
-          </a:ln>
-        </p:spPr>
-        <p:style>
-          <a:lnRef idx="2">
-            <a:schemeClr val="accent1">
-              <a:shade val="15000"/>
-            </a:schemeClr>
-          </a:lnRef>
-          <a:fillRef idx="1">
-            <a:schemeClr val="accent1"/>
-          </a:fillRef>
-          <a:effectRef idx="0">
-            <a:schemeClr val="accent1"/>
-          </a:effectRef>
-          <a:fontRef idx="minor">
-            <a:schemeClr val="lt1"/>
-          </a:fontRef>
-        </p:style>
-        <p:txBody>
-          <a:bodyPr rtlCol="0" anchor="ctr"/>
-          <a:lstStyle/>
-          <a:p>
-            <a:pPr algn="ctr"/>
-            <a:endParaRPr lang="en-US" dirty="0">
-              <a:solidFill>
-                <a:schemeClr val="tx1"/>
-              </a:solidFill>
-            </a:endParaRPr>
-          </a:p>
-        </p:txBody>
-      </p:sp>
-      <p:sp>
-        <p:nvSpPr>
-          <p:cNvPr id="59" name="TextBox 58">
-            <a:extLst>
-              <a:ext uri="{FF2B5EF4-FFF2-40B4-BE49-F238E27FC236}">
-                <a16:creationId xmlns:a16="http://schemas.microsoft.com/office/drawing/2014/main" id="{2D98810B-F604-E76F-CD3E-089D1713CCC8}"/>
-              </a:ext>
-            </a:extLst>
-          </p:cNvPr>
-          <p:cNvSpPr txBox="1"/>
-          <p:nvPr/>
-        </p:nvSpPr>
-        <p:spPr>
-          <a:xfrm>
-            <a:off x="8804181" y="3933596"/>
-            <a:ext cx="1073400" cy="276999"/>
-          </a:xfrm>
-          <a:prstGeom prst="rect">
-            <a:avLst/>
-          </a:prstGeom>
-          <a:noFill/>
-        </p:spPr>
-        <p:txBody>
-          <a:bodyPr wrap="square" rtlCol="0">
-            <a:spAutoFit/>
-          </a:bodyPr>
-          <a:lstStyle/>
-          <a:p>
-            <a:r>
-              <a:rPr lang="en-US" sz="1200" dirty="0">
-                <a:solidFill>
-                  <a:srgbClr val="FF0000"/>
-                </a:solidFill>
-              </a:rPr>
-              <a:t>Grid-3 (0,3)</a:t>
-            </a:r>
-          </a:p>
-        </p:txBody>
-      </p:sp>
-      <p:sp>
-        <p:nvSpPr>
-          <p:cNvPr id="73" name="Rectangle: Rounded Corners 72">
-            <a:extLst>
-              <a:ext uri="{FF2B5EF4-FFF2-40B4-BE49-F238E27FC236}">
-                <a16:creationId xmlns:a16="http://schemas.microsoft.com/office/drawing/2014/main" id="{A953441F-DD1B-7106-51AF-1F86DEAF97D6}"/>
-              </a:ext>
-            </a:extLst>
-          </p:cNvPr>
-          <p:cNvSpPr/>
-          <p:nvPr/>
-        </p:nvSpPr>
-        <p:spPr>
-          <a:xfrm>
-            <a:off x="10225813" y="3912192"/>
-            <a:ext cx="891268" cy="1347825"/>
-          </a:xfrm>
-          <a:prstGeom prst="roundRect">
-            <a:avLst/>
-          </a:prstGeom>
-          <a:noFill/>
-          <a:ln>
-            <a:prstDash val="sysDash"/>
-          </a:ln>
-        </p:spPr>
-        <p:style>
-          <a:lnRef idx="2">
-            <a:schemeClr val="accent1">
-              <a:shade val="15000"/>
-            </a:schemeClr>
-          </a:lnRef>
-          <a:fillRef idx="1">
-            <a:schemeClr val="accent1"/>
-          </a:fillRef>
-          <a:effectRef idx="0">
-            <a:schemeClr val="accent1"/>
-          </a:effectRef>
-          <a:fontRef idx="minor">
-            <a:schemeClr val="lt1"/>
-          </a:fontRef>
-        </p:style>
-        <p:txBody>
-          <a:bodyPr rtlCol="0" anchor="ctr"/>
-          <a:lstStyle/>
-          <a:p>
-            <a:pPr algn="ctr"/>
-            <a:endParaRPr lang="en-US" dirty="0">
-              <a:solidFill>
-                <a:schemeClr val="tx1"/>
-              </a:solidFill>
-            </a:endParaRPr>
-          </a:p>
-        </p:txBody>
-      </p:sp>
-      <p:sp>
-        <p:nvSpPr>
-          <p:cNvPr id="74" name="TextBox 73">
-            <a:extLst>
-              <a:ext uri="{FF2B5EF4-FFF2-40B4-BE49-F238E27FC236}">
-                <a16:creationId xmlns:a16="http://schemas.microsoft.com/office/drawing/2014/main" id="{F5341098-0657-3E7C-A62A-85118C6F2B10}"/>
-              </a:ext>
-            </a:extLst>
-          </p:cNvPr>
-          <p:cNvSpPr txBox="1"/>
-          <p:nvPr/>
-        </p:nvSpPr>
-        <p:spPr>
-          <a:xfrm>
-            <a:off x="10225813" y="3933596"/>
-            <a:ext cx="1073400" cy="276999"/>
-          </a:xfrm>
-          <a:prstGeom prst="rect">
-            <a:avLst/>
-          </a:prstGeom>
-          <a:noFill/>
-        </p:spPr>
-        <p:txBody>
-          <a:bodyPr wrap="square" rtlCol="0">
-            <a:spAutoFit/>
-          </a:bodyPr>
-          <a:lstStyle/>
-          <a:p>
-            <a:r>
-              <a:rPr lang="en-US" sz="1200" dirty="0">
-                <a:solidFill>
-                  <a:srgbClr val="FF0000"/>
-                </a:solidFill>
-              </a:rPr>
-              <a:t>Grid-3 (0,8)</a:t>
-            </a:r>
-          </a:p>
-        </p:txBody>
-      </p:sp>
-      <p:sp>
-        <p:nvSpPr>
-          <p:cNvPr id="75" name="TextBox 74">
-            <a:extLst>
-              <a:ext uri="{FF2B5EF4-FFF2-40B4-BE49-F238E27FC236}">
-                <a16:creationId xmlns:a16="http://schemas.microsoft.com/office/drawing/2014/main" id="{B3A13985-8F40-6315-7133-1F6B0A64B65D}"/>
-              </a:ext>
-            </a:extLst>
-          </p:cNvPr>
-          <p:cNvSpPr txBox="1"/>
-          <p:nvPr/>
-        </p:nvSpPr>
-        <p:spPr>
-          <a:xfrm>
-            <a:off x="6053452" y="5374124"/>
-            <a:ext cx="5978639" cy="1245576"/>
-          </a:xfrm>
-          <a:prstGeom prst="rect">
-            <a:avLst/>
-          </a:prstGeom>
-          <a:noFill/>
-          <a:ln>
-            <a:solidFill>
-              <a:schemeClr val="accent1"/>
-            </a:solidFill>
-          </a:ln>
-        </p:spPr>
-        <p:txBody>
-          <a:bodyPr wrap="square" rtlCol="0">
-            <a:noAutofit/>
-          </a:bodyPr>
-          <a:lstStyle/>
-          <a:p>
-            <a:r>
-              <a:rPr lang="en-US" dirty="0"/>
-              <a:t>Play/Show Score Info </a:t>
-            </a:r>
-          </a:p>
-        </p:txBody>
-      </p:sp>
-      <p:sp>
-        <p:nvSpPr>
-          <p:cNvPr id="79" name="TextBox 78">
-            <a:extLst>
-              <a:ext uri="{FF2B5EF4-FFF2-40B4-BE49-F238E27FC236}">
-                <a16:creationId xmlns:a16="http://schemas.microsoft.com/office/drawing/2014/main" id="{01513594-8D05-4C26-FD96-4826DC01B5A6}"/>
-              </a:ext>
-            </a:extLst>
-          </p:cNvPr>
-          <p:cNvSpPr txBox="1"/>
-          <p:nvPr/>
-        </p:nvSpPr>
-        <p:spPr>
-          <a:xfrm>
-            <a:off x="9697130" y="5438116"/>
-            <a:ext cx="1073400" cy="276999"/>
-          </a:xfrm>
-          <a:prstGeom prst="rect">
-            <a:avLst/>
-          </a:prstGeom>
-          <a:noFill/>
-        </p:spPr>
-        <p:txBody>
-          <a:bodyPr wrap="square" rtlCol="0">
-            <a:spAutoFit/>
-          </a:bodyPr>
-          <a:lstStyle/>
-          <a:p>
-            <a:r>
-              <a:rPr lang="en-US" sz="1200" dirty="0">
-                <a:solidFill>
-                  <a:srgbClr val="FF0000"/>
-                </a:solidFill>
-              </a:rPr>
-              <a:t>Grid-2 (3,1-3)</a:t>
-            </a:r>
-          </a:p>
-        </p:txBody>
-      </p:sp>
-      <p:sp>
-        <p:nvSpPr>
-          <p:cNvPr id="81" name="TextBox 80">
-            <a:extLst>
-              <a:ext uri="{FF2B5EF4-FFF2-40B4-BE49-F238E27FC236}">
-                <a16:creationId xmlns:a16="http://schemas.microsoft.com/office/drawing/2014/main" id="{7AF27D2F-B663-6478-618E-EF206F7E9644}"/>
-              </a:ext>
-            </a:extLst>
-          </p:cNvPr>
-          <p:cNvSpPr txBox="1"/>
-          <p:nvPr/>
-        </p:nvSpPr>
-        <p:spPr>
-          <a:xfrm>
-            <a:off x="6134406" y="5705949"/>
-            <a:ext cx="5897686" cy="819209"/>
-          </a:xfrm>
-          <a:prstGeom prst="rect">
-            <a:avLst/>
-          </a:prstGeom>
-          <a:noFill/>
-          <a:ln>
-            <a:solidFill>
-              <a:schemeClr val="accent1">
-                <a:shade val="15000"/>
-              </a:schemeClr>
-            </a:solidFill>
-          </a:ln>
-        </p:spPr>
-        <p:txBody>
-          <a:bodyPr wrap="none" rtlCol="0">
-            <a:noAutofit/>
-          </a:bodyPr>
-          <a:lstStyle/>
-          <a:p>
-            <a:r>
-              <a:rPr lang="en-US" sz="1400" dirty="0"/>
-              <a:t>Player 2 scored 15 for 2: KH 5S</a:t>
-            </a:r>
-          </a:p>
-          <a:p>
-            <a:r>
-              <a:rPr lang="en-US" sz="1400" dirty="0"/>
-              <a:t>Player 1 scored pair for 2; 5S 5D </a:t>
-            </a:r>
-          </a:p>
-        </p:txBody>
-      </p:sp>
-      <p:sp>
-        <p:nvSpPr>
-          <p:cNvPr id="82" name="TextBox 81">
-            <a:extLst>
-              <a:ext uri="{FF2B5EF4-FFF2-40B4-BE49-F238E27FC236}">
-                <a16:creationId xmlns:a16="http://schemas.microsoft.com/office/drawing/2014/main" id="{5B1D01CF-6C1B-1941-28CE-47E8E876C0AB}"/>
-              </a:ext>
-            </a:extLst>
-          </p:cNvPr>
-          <p:cNvSpPr txBox="1"/>
-          <p:nvPr/>
-        </p:nvSpPr>
-        <p:spPr>
-          <a:xfrm>
-            <a:off x="8995761" y="5809174"/>
-            <a:ext cx="1073400" cy="276999"/>
-          </a:xfrm>
-          <a:prstGeom prst="rect">
-            <a:avLst/>
-          </a:prstGeom>
-          <a:noFill/>
-        </p:spPr>
-        <p:txBody>
-          <a:bodyPr wrap="square" rtlCol="0">
-            <a:spAutoFit/>
-          </a:bodyPr>
-          <a:lstStyle/>
-          <a:p>
-            <a:r>
-              <a:rPr lang="en-US" sz="1200" dirty="0">
-                <a:solidFill>
-                  <a:srgbClr val="FF0000"/>
-                </a:solidFill>
-              </a:rPr>
-              <a:t>Grid-3 (0,0)</a:t>
-            </a:r>
-          </a:p>
-        </p:txBody>
-      </p:sp>
-      <p:sp>
-        <p:nvSpPr>
-          <p:cNvPr id="84" name="Rectangle: Rounded Corners 83">
-            <a:extLst>
-              <a:ext uri="{FF2B5EF4-FFF2-40B4-BE49-F238E27FC236}">
-                <a16:creationId xmlns:a16="http://schemas.microsoft.com/office/drawing/2014/main" id="{C64CD230-4282-5D76-2FCA-4C2A0F275945}"/>
-              </a:ext>
-            </a:extLst>
-          </p:cNvPr>
-          <p:cNvSpPr/>
-          <p:nvPr/>
-        </p:nvSpPr>
-        <p:spPr>
-          <a:xfrm>
-            <a:off x="10000907" y="2280370"/>
-            <a:ext cx="891268" cy="1347825"/>
-          </a:xfrm>
-          <a:prstGeom prst="roundRect">
-            <a:avLst/>
-          </a:prstGeom>
-          <a:noFill/>
-          <a:ln>
-            <a:prstDash val="sysDash"/>
-          </a:ln>
-        </p:spPr>
-        <p:style>
-          <a:lnRef idx="2">
-            <a:schemeClr val="accent1">
-              <a:shade val="15000"/>
-            </a:schemeClr>
-          </a:lnRef>
-          <a:fillRef idx="1">
-            <a:schemeClr val="accent1"/>
-          </a:fillRef>
-          <a:effectRef idx="0">
-            <a:schemeClr val="accent1"/>
-          </a:effectRef>
-          <a:fontRef idx="minor">
-            <a:schemeClr val="lt1"/>
-          </a:fontRef>
-        </p:style>
-        <p:txBody>
-          <a:bodyPr rtlCol="0" anchor="ctr"/>
-          <a:lstStyle/>
-          <a:p>
-            <a:pPr algn="ctr"/>
-            <a:endParaRPr lang="en-US" dirty="0">
-              <a:solidFill>
-                <a:schemeClr val="tx1"/>
-              </a:solidFill>
-            </a:endParaRPr>
-          </a:p>
-        </p:txBody>
-      </p:sp>
-      <p:sp>
-        <p:nvSpPr>
-          <p:cNvPr id="85" name="Rectangle: Rounded Corners 84">
-            <a:extLst>
-              <a:ext uri="{FF2B5EF4-FFF2-40B4-BE49-F238E27FC236}">
-                <a16:creationId xmlns:a16="http://schemas.microsoft.com/office/drawing/2014/main" id="{17AECAA6-9EB7-4E82-3AF5-0D84838AAAFE}"/>
-              </a:ext>
-            </a:extLst>
-          </p:cNvPr>
-          <p:cNvSpPr/>
-          <p:nvPr/>
-        </p:nvSpPr>
-        <p:spPr>
-          <a:xfrm>
-            <a:off x="10914987" y="2271603"/>
-            <a:ext cx="891268" cy="1347825"/>
-          </a:xfrm>
-          <a:prstGeom prst="roundRect">
-            <a:avLst/>
-          </a:prstGeom>
-          <a:noFill/>
-          <a:ln>
-            <a:prstDash val="sysDash"/>
-          </a:ln>
-        </p:spPr>
-        <p:style>
-          <a:lnRef idx="2">
-            <a:schemeClr val="accent1">
-              <a:shade val="15000"/>
-            </a:schemeClr>
-          </a:lnRef>
-          <a:fillRef idx="1">
-            <a:schemeClr val="accent1"/>
-          </a:fillRef>
-          <a:effectRef idx="0">
-            <a:schemeClr val="accent1"/>
-          </a:effectRef>
-          <a:fontRef idx="minor">
-            <a:schemeClr val="lt1"/>
-          </a:fontRef>
-        </p:style>
-        <p:txBody>
-          <a:bodyPr rtlCol="0" anchor="ctr"/>
-          <a:lstStyle/>
-          <a:p>
-            <a:pPr algn="ctr"/>
-            <a:endParaRPr lang="en-US" dirty="0">
-              <a:solidFill>
-                <a:schemeClr val="tx1"/>
-              </a:solidFill>
-            </a:endParaRPr>
-          </a:p>
-        </p:txBody>
-      </p:sp>
-      <p:sp>
-        <p:nvSpPr>
-          <p:cNvPr id="87" name="TextBox 86">
-            <a:extLst>
-              <a:ext uri="{FF2B5EF4-FFF2-40B4-BE49-F238E27FC236}">
-                <a16:creationId xmlns:a16="http://schemas.microsoft.com/office/drawing/2014/main" id="{07F08FEA-3508-B93B-5693-A5969692DB41}"/>
-              </a:ext>
-            </a:extLst>
-          </p:cNvPr>
-          <p:cNvSpPr txBox="1"/>
-          <p:nvPr/>
-        </p:nvSpPr>
-        <p:spPr>
-          <a:xfrm>
-            <a:off x="9992339" y="2324663"/>
-            <a:ext cx="1073400" cy="276999"/>
-          </a:xfrm>
-          <a:prstGeom prst="rect">
-            <a:avLst/>
-          </a:prstGeom>
-          <a:noFill/>
-        </p:spPr>
-        <p:txBody>
-          <a:bodyPr wrap="square" rtlCol="0">
-            <a:spAutoFit/>
-          </a:bodyPr>
-          <a:lstStyle/>
-          <a:p>
-            <a:r>
-              <a:rPr lang="en-US" sz="1200" dirty="0">
-                <a:solidFill>
-                  <a:srgbClr val="FF0000"/>
-                </a:solidFill>
-              </a:rPr>
-              <a:t>Grid-3 (0,4)</a:t>
-            </a:r>
-          </a:p>
-        </p:txBody>
-      </p:sp>
-      <p:sp>
-        <p:nvSpPr>
-          <p:cNvPr id="88" name="TextBox 87">
-            <a:extLst>
-              <a:ext uri="{FF2B5EF4-FFF2-40B4-BE49-F238E27FC236}">
-                <a16:creationId xmlns:a16="http://schemas.microsoft.com/office/drawing/2014/main" id="{B1F61F3B-D1EC-21B2-AD05-1DB15D976197}"/>
-              </a:ext>
-            </a:extLst>
-          </p:cNvPr>
-          <p:cNvSpPr txBox="1"/>
-          <p:nvPr/>
-        </p:nvSpPr>
-        <p:spPr>
-          <a:xfrm>
-            <a:off x="10937485" y="2295466"/>
-            <a:ext cx="1073400" cy="276999"/>
-          </a:xfrm>
-          <a:prstGeom prst="rect">
-            <a:avLst/>
-          </a:prstGeom>
-          <a:noFill/>
-        </p:spPr>
-        <p:txBody>
-          <a:bodyPr wrap="square" rtlCol="0">
-            <a:spAutoFit/>
-          </a:bodyPr>
-          <a:lstStyle/>
-          <a:p>
-            <a:r>
-              <a:rPr lang="en-US" sz="1200" dirty="0">
-                <a:solidFill>
-                  <a:srgbClr val="FF0000"/>
-                </a:solidFill>
-              </a:rPr>
-              <a:t>Grid-3 (0,5)</a:t>
-            </a:r>
-          </a:p>
-        </p:txBody>
-      </p:sp>
-      <p:sp>
-        <p:nvSpPr>
-          <p:cNvPr id="21" name="TextBox 20">
-            <a:extLst>
-              <a:ext uri="{FF2B5EF4-FFF2-40B4-BE49-F238E27FC236}">
-                <a16:creationId xmlns:a16="http://schemas.microsoft.com/office/drawing/2014/main" id="{588D20FE-DE47-45EB-E25F-61EE691125EC}"/>
-              </a:ext>
-            </a:extLst>
-          </p:cNvPr>
-          <p:cNvSpPr txBox="1"/>
-          <p:nvPr/>
-        </p:nvSpPr>
-        <p:spPr>
-          <a:xfrm rot="16200000">
-            <a:off x="-585854" y="913188"/>
-            <a:ext cx="1740713" cy="276999"/>
-          </a:xfrm>
-          <a:prstGeom prst="rect">
-            <a:avLst/>
-          </a:prstGeom>
-          <a:noFill/>
-        </p:spPr>
-        <p:txBody>
-          <a:bodyPr wrap="square" rtlCol="0">
-            <a:spAutoFit/>
-          </a:bodyPr>
-          <a:lstStyle/>
-          <a:p>
-            <a:r>
-              <a:rPr lang="en-US" sz="1200" dirty="0">
-                <a:solidFill>
-                  <a:srgbClr val="FF0000"/>
-                </a:solidFill>
-              </a:rPr>
-              <a:t>Grid-0 (row=0,colum=0)</a:t>
+              <a:t>Grid-1 (row=0,column=0)</a:t>
             </a:r>
           </a:p>
         </p:txBody>
@@ -6386,7 +4145,7 @@
           <p:cNvPr id="31" name="TextBox 30">
             <a:extLst>
               <a:ext uri="{FF2B5EF4-FFF2-40B4-BE49-F238E27FC236}">
-                <a16:creationId xmlns:a16="http://schemas.microsoft.com/office/drawing/2014/main" id="{DC9F2AD9-5FC4-BB93-AC2E-4EA8180327C2}"/>
+                <a16:creationId xmlns:a16="http://schemas.microsoft.com/office/drawing/2014/main" id="{CD7F29CB-1452-BA1C-F360-02338B61FF8B}"/>
               </a:ext>
             </a:extLst>
           </p:cNvPr>
@@ -6411,42 +4170,7 @@
           <a:p>
             <a:r>
               <a:rPr lang="en-US" dirty="0"/>
-              <a:t>V3.0</a:t>
-            </a:r>
-          </a:p>
-        </p:txBody>
-      </p:sp>
-      <p:sp>
-        <p:nvSpPr>
-          <p:cNvPr id="46" name="TextBox 45">
-            <a:extLst>
-              <a:ext uri="{FF2B5EF4-FFF2-40B4-BE49-F238E27FC236}">
-                <a16:creationId xmlns:a16="http://schemas.microsoft.com/office/drawing/2014/main" id="{BA251834-398A-B309-0EAB-A887611A7CE8}"/>
-              </a:ext>
-            </a:extLst>
-          </p:cNvPr>
-          <p:cNvSpPr txBox="1"/>
-          <p:nvPr/>
-        </p:nvSpPr>
-        <p:spPr>
-          <a:xfrm>
-            <a:off x="9686883" y="4107199"/>
-            <a:ext cx="538930" cy="707886"/>
-          </a:xfrm>
-          <a:prstGeom prst="rect">
-            <a:avLst/>
-          </a:prstGeom>
-          <a:noFill/>
-        </p:spPr>
-        <p:txBody>
-          <a:bodyPr wrap="none" rtlCol="0" anchor="ctr">
-            <a:spAutoFit/>
-          </a:bodyPr>
-          <a:lstStyle/>
-          <a:p>
-            <a:r>
-              <a:rPr lang="en-US" sz="4000" dirty="0"/>
-              <a:t>…</a:t>
+              <a:t>V1.0</a:t>
             </a:r>
           </a:p>
         </p:txBody>
@@ -6456,7 +4180,7 @@
           <p:cNvPr id="51" name="TextBox 50">
             <a:extLst>
               <a:ext uri="{FF2B5EF4-FFF2-40B4-BE49-F238E27FC236}">
-                <a16:creationId xmlns:a16="http://schemas.microsoft.com/office/drawing/2014/main" id="{79306DB4-6861-FC48-9B14-4285C4B1D0C1}"/>
+                <a16:creationId xmlns:a16="http://schemas.microsoft.com/office/drawing/2014/main" id="{CDF3C274-CBE3-6AA9-3A1E-BD448CE72DFD}"/>
               </a:ext>
             </a:extLst>
           </p:cNvPr>
@@ -6486,7 +4210,7 @@
           <a:p>
             <a:r>
               <a:rPr lang="en-US" dirty="0"/>
-              <a:t>Query</a:t>
+              <a:t>Beats Per Minute</a:t>
             </a:r>
           </a:p>
         </p:txBody>
@@ -6496,7 +4220,7 @@
           <p:cNvPr id="54" name="TextBox 53">
             <a:extLst>
               <a:ext uri="{FF2B5EF4-FFF2-40B4-BE49-F238E27FC236}">
-                <a16:creationId xmlns:a16="http://schemas.microsoft.com/office/drawing/2014/main" id="{248CC959-630A-6FED-95E6-372080F08CD3}"/>
+                <a16:creationId xmlns:a16="http://schemas.microsoft.com/office/drawing/2014/main" id="{203BCFD8-4063-78B8-4149-EC31B766CC67}"/>
               </a:ext>
             </a:extLst>
           </p:cNvPr>
@@ -6525,37 +4249,8 @@
                   <a:srgbClr val="FF0000"/>
                 </a:solidFill>
               </a:rPr>
-              <a:t>Grid-1 </a:t>
-            </a:r>
-            <a:r>
-              <a:rPr lang="en-US" sz="1200">
-                <a:solidFill>
-                  <a:srgbClr val="FF0000"/>
-                </a:solidFill>
-              </a:rPr>
-              <a:t>(0,</a:t>
-            </a:r>
-            <a:r>
-              <a:rPr lang="en-US" sz="1200" dirty="0">
-                <a:solidFill>
-                  <a:srgbClr val="FF0000"/>
-                </a:solidFill>
-              </a:rPr>
-              <a:t>0</a:t>
-            </a:r>
-            <a:r>
-              <a:rPr lang="en-US" sz="1200">
-                <a:solidFill>
-                  <a:srgbClr val="FF0000"/>
-                </a:solidFill>
-              </a:rPr>
-              <a:t>)</a:t>
-            </a:r>
-            <a:endParaRPr lang="en-US" sz="1200" dirty="0">
-              <a:solidFill>
-                <a:srgbClr val="FF0000"/>
-              </a:solidFill>
-            </a:endParaRPr>
+              <a:t>Grid-2 (0-2,0)</a:t>
+            </a:r>
           </a:p>
         </p:txBody>
       </p:sp>
@@ -6564,7 +4259,7 @@
           <p:cNvPr id="14" name="Rectangle 13">
             <a:extLst>
               <a:ext uri="{FF2B5EF4-FFF2-40B4-BE49-F238E27FC236}">
-                <a16:creationId xmlns:a16="http://schemas.microsoft.com/office/drawing/2014/main" id="{B037FC86-4C56-0F86-B011-DC3439F7B15B}"/>
+                <a16:creationId xmlns:a16="http://schemas.microsoft.com/office/drawing/2014/main" id="{9E72C6BB-EA5A-474B-63B2-F84F5788BB9C}"/>
               </a:ext>
             </a:extLst>
           </p:cNvPr>
@@ -6573,8 +4268,8 @@
         </p:nvSpPr>
         <p:spPr>
           <a:xfrm>
-            <a:off x="612666" y="595407"/>
-            <a:ext cx="2433811" cy="661639"/>
+            <a:off x="1228687" y="837379"/>
+            <a:ext cx="1073400" cy="5103827"/>
           </a:xfrm>
           <a:prstGeom prst="rect">
             <a:avLst/>
@@ -6603,22 +4298,30 @@
           <a:p>
             <a:pPr algn="ctr"/>
             <a:r>
+              <a:rPr lang="en-US" sz="1400" dirty="0" err="1">
+                <a:solidFill>
+                  <a:schemeClr val="tx1"/>
+                </a:solidFill>
+              </a:rPr>
+              <a:t>tk.Scale</a:t>
+            </a:r>
+            <a:r>
               <a:rPr lang="en-US" sz="1400" dirty="0">
                 <a:solidFill>
                   <a:schemeClr val="tx1"/>
                 </a:solidFill>
               </a:rPr>
-              <a:t>Message box with displaying query text, e.g. “Which card do you wish to play?”</a:t>
-            </a:r>
-          </a:p>
-        </p:txBody>
-      </p:sp>
-      <p:sp>
-        <p:nvSpPr>
-          <p:cNvPr id="15" name="Rectangle 14">
-            <a:extLst>
-              <a:ext uri="{FF2B5EF4-FFF2-40B4-BE49-F238E27FC236}">
-                <a16:creationId xmlns:a16="http://schemas.microsoft.com/office/drawing/2014/main" id="{0EAA9EC4-39F7-179B-3E7A-E2874F338328}"/>
+              <a:t> object, oriented vertically, for changing the BPM of the metronome</a:t>
+            </a:r>
+          </a:p>
+        </p:txBody>
+      </p:sp>
+      <p:sp>
+        <p:nvSpPr>
+          <p:cNvPr id="22" name="Rectangle: Rounded Corners 21">
+            <a:extLst>
+              <a:ext uri="{FF2B5EF4-FFF2-40B4-BE49-F238E27FC236}">
+                <a16:creationId xmlns:a16="http://schemas.microsoft.com/office/drawing/2014/main" id="{229DD63A-1BCB-A9C9-4F9A-B8E01A95A3C0}"/>
               </a:ext>
             </a:extLst>
           </p:cNvPr>
@@ -6627,91 +4330,7 @@
         </p:nvSpPr>
         <p:spPr>
           <a:xfrm>
-            <a:off x="602265" y="1356380"/>
-            <a:ext cx="2444212" cy="915223"/>
-          </a:xfrm>
-          <a:prstGeom prst="rect">
-            <a:avLst/>
-          </a:prstGeom>
-          <a:noFill/>
-        </p:spPr>
-        <p:style>
-          <a:lnRef idx="2">
-            <a:schemeClr val="accent1">
-              <a:shade val="15000"/>
-            </a:schemeClr>
-          </a:lnRef>
-          <a:fillRef idx="1">
-            <a:schemeClr val="accent1"/>
-          </a:fillRef>
-          <a:effectRef idx="0">
-            <a:schemeClr val="accent1"/>
-          </a:effectRef>
-          <a:fontRef idx="minor">
-            <a:schemeClr val="lt1"/>
-          </a:fontRef>
-        </p:style>
-        <p:txBody>
-          <a:bodyPr rtlCol="0" anchor="ctr"/>
-          <a:lstStyle/>
-          <a:p>
-            <a:pPr algn="ctr"/>
-            <a:r>
-              <a:rPr lang="en-US" sz="1400" dirty="0">
-                <a:solidFill>
-                  <a:schemeClr val="tx1"/>
-                </a:solidFill>
-              </a:rPr>
-              <a:t>(List box with choices)</a:t>
-            </a:r>
-          </a:p>
-          <a:p>
-            <a:r>
-              <a:rPr lang="en-US" sz="1400" dirty="0">
-                <a:solidFill>
-                  <a:schemeClr val="tx1"/>
-                </a:solidFill>
-              </a:rPr>
-              <a:t>QH</a:t>
-            </a:r>
-          </a:p>
-          <a:p>
-            <a:r>
-              <a:rPr lang="en-US" sz="1400" dirty="0">
-                <a:solidFill>
-                  <a:schemeClr val="tx1"/>
-                </a:solidFill>
-              </a:rPr>
-              <a:t>6S</a:t>
-            </a:r>
-          </a:p>
-          <a:p>
-            <a:r>
-              <a:rPr lang="en-US" sz="1400" dirty="0">
-                <a:solidFill>
-                  <a:schemeClr val="tx1"/>
-                </a:solidFill>
-              </a:rPr>
-              <a:t>go</a:t>
-            </a:r>
-          </a:p>
-        </p:txBody>
-      </p:sp>
-      <p:sp>
-        <p:nvSpPr>
-          <p:cNvPr id="22" name="Rectangle: Rounded Corners 21">
-            <a:extLst>
-              <a:ext uri="{FF2B5EF4-FFF2-40B4-BE49-F238E27FC236}">
-                <a16:creationId xmlns:a16="http://schemas.microsoft.com/office/drawing/2014/main" id="{18B0A0A0-462A-608C-A011-424B72E8D082}"/>
-              </a:ext>
-            </a:extLst>
-          </p:cNvPr>
-          <p:cNvSpPr/>
-          <p:nvPr/>
-        </p:nvSpPr>
-        <p:spPr>
-          <a:xfrm>
-            <a:off x="1308481" y="2391341"/>
+            <a:off x="4102388" y="5873463"/>
             <a:ext cx="1034384" cy="420641"/>
           </a:xfrm>
           <a:prstGeom prst="roundRect">
@@ -6747,7 +4366,7 @@
             <a:pPr algn="ctr"/>
             <a:r>
               <a:rPr lang="en-US" dirty="0"/>
-              <a:t>Choose</a:t>
+              <a:t>Start</a:t>
             </a:r>
           </a:p>
         </p:txBody>
@@ -6757,7 +4376,7 @@
           <p:cNvPr id="25" name="TextBox 24">
             <a:extLst>
               <a:ext uri="{FF2B5EF4-FFF2-40B4-BE49-F238E27FC236}">
-                <a16:creationId xmlns:a16="http://schemas.microsoft.com/office/drawing/2014/main" id="{1A978136-3716-74B9-6DB8-84EF6135E191}"/>
+                <a16:creationId xmlns:a16="http://schemas.microsoft.com/office/drawing/2014/main" id="{32D43B89-C710-0538-6E0C-C543DCF2770F}"/>
               </a:ext>
             </a:extLst>
           </p:cNvPr>
@@ -6766,7 +4385,7 @@
         </p:nvSpPr>
         <p:spPr>
           <a:xfrm>
-            <a:off x="1742025" y="2780368"/>
+            <a:off x="4063372" y="5647373"/>
             <a:ext cx="1073400" cy="276999"/>
           </a:xfrm>
           <a:prstGeom prst="rect">
@@ -6786,7 +4405,7 @@
                   <a:srgbClr val="FF0000"/>
                 </a:solidFill>
               </a:rPr>
-              <a:t>Grid-2 (2,0)</a:t>
+              <a:t>Grid-3 (0,0)</a:t>
             </a:r>
           </a:p>
         </p:txBody>
@@ -6796,7 +4415,7 @@
           <p:cNvPr id="28" name="TextBox 27">
             <a:extLst>
               <a:ext uri="{FF2B5EF4-FFF2-40B4-BE49-F238E27FC236}">
-                <a16:creationId xmlns:a16="http://schemas.microsoft.com/office/drawing/2014/main" id="{36008803-5DCA-A2FF-40BC-94EAD427E4EE}"/>
+                <a16:creationId xmlns:a16="http://schemas.microsoft.com/office/drawing/2014/main" id="{263D47EC-CF9A-0ADA-630D-5F8C6725BBA1}"/>
               </a:ext>
             </a:extLst>
           </p:cNvPr>
@@ -6805,7 +4424,7 @@
         </p:nvSpPr>
         <p:spPr>
           <a:xfrm>
-            <a:off x="2054329" y="2068374"/>
+            <a:off x="3241188" y="5007887"/>
             <a:ext cx="1073400" cy="276999"/>
           </a:xfrm>
           <a:prstGeom prst="rect">
@@ -6825,7 +4444,7 @@
                   <a:srgbClr val="FF0000"/>
                 </a:solidFill>
               </a:rPr>
-              <a:t>Grid-2 (1,0)</a:t>
+              <a:t>Grid-3 (0,0)</a:t>
             </a:r>
           </a:p>
         </p:txBody>
@@ -6835,7 +4454,7 @@
           <p:cNvPr id="34" name="TextBox 33">
             <a:extLst>
               <a:ext uri="{FF2B5EF4-FFF2-40B4-BE49-F238E27FC236}">
-                <a16:creationId xmlns:a16="http://schemas.microsoft.com/office/drawing/2014/main" id="{1394D58B-0278-E180-27FB-DE41EFE112B0}"/>
+                <a16:creationId xmlns:a16="http://schemas.microsoft.com/office/drawing/2014/main" id="{00EC43CE-A094-275B-D3DA-C3FAD23B327A}"/>
               </a:ext>
             </a:extLst>
           </p:cNvPr>
@@ -6844,7 +4463,7 @@
         </p:nvSpPr>
         <p:spPr>
           <a:xfrm>
-            <a:off x="639615" y="369638"/>
+            <a:off x="1320091" y="826423"/>
             <a:ext cx="1073400" cy="276999"/>
           </a:xfrm>
           <a:prstGeom prst="rect">
@@ -6864,35 +4483,192 @@
                   <a:srgbClr val="FF0000"/>
                 </a:solidFill>
               </a:rPr>
-              <a:t>Grid-2 (0,0)</a:t>
-            </a:r>
-          </a:p>
-        </p:txBody>
-      </p:sp>
-      <p:sp>
-        <p:nvSpPr>
-          <p:cNvPr id="16" name="Rectangle 15">
-            <a:extLst>
-              <a:ext uri="{FF2B5EF4-FFF2-40B4-BE49-F238E27FC236}">
-                <a16:creationId xmlns:a16="http://schemas.microsoft.com/office/drawing/2014/main" id="{2B55F4CD-9BDF-127C-E889-E8CAC62AFB1A}"/>
-              </a:ext>
-            </a:extLst>
-          </p:cNvPr>
-          <p:cNvSpPr/>
+              <a:t>Grid-3 (0,0)</a:t>
+            </a:r>
+          </a:p>
+        </p:txBody>
+      </p:sp>
+      <p:sp>
+        <p:nvSpPr>
+          <p:cNvPr id="57" name="TextBox 56">
+            <a:extLst>
+              <a:ext uri="{FF2B5EF4-FFF2-40B4-BE49-F238E27FC236}">
+                <a16:creationId xmlns:a16="http://schemas.microsoft.com/office/drawing/2014/main" id="{87FA4105-F12E-9D39-41C9-C03C25A7632B}"/>
+              </a:ext>
+            </a:extLst>
+          </p:cNvPr>
+          <p:cNvSpPr txBox="1"/>
           <p:nvPr/>
         </p:nvSpPr>
         <p:spPr>
           <a:xfrm>
-            <a:off x="3285954" y="37170"/>
-            <a:ext cx="8859057" cy="6675542"/>
+            <a:off x="3285954" y="4347679"/>
+            <a:ext cx="2745975" cy="1049271"/>
           </a:xfrm>
           <a:prstGeom prst="rect">
             <a:avLst/>
           </a:prstGeom>
           <a:noFill/>
           <a:ln>
-            <a:prstDash val="sysDot"/>
+            <a:solidFill>
+              <a:schemeClr val="accent1"/>
+            </a:solidFill>
           </a:ln>
+        </p:spPr>
+        <p:txBody>
+          <a:bodyPr wrap="square" rtlCol="0">
+            <a:noAutofit/>
+          </a:bodyPr>
+          <a:lstStyle/>
+          <a:p>
+            <a:r>
+              <a:rPr lang="en-US" dirty="0"/>
+              <a:t>Rhythm</a:t>
+            </a:r>
+          </a:p>
+        </p:txBody>
+      </p:sp>
+      <p:sp>
+        <p:nvSpPr>
+          <p:cNvPr id="60" name="TextBox 59">
+            <a:extLst>
+              <a:ext uri="{FF2B5EF4-FFF2-40B4-BE49-F238E27FC236}">
+                <a16:creationId xmlns:a16="http://schemas.microsoft.com/office/drawing/2014/main" id="{7842D9FA-DDD0-9A26-CF38-53C287759050}"/>
+              </a:ext>
+            </a:extLst>
+          </p:cNvPr>
+          <p:cNvSpPr txBox="1"/>
+          <p:nvPr/>
+        </p:nvSpPr>
+        <p:spPr>
+          <a:xfrm>
+            <a:off x="3295970" y="5396950"/>
+            <a:ext cx="2745975" cy="1219779"/>
+          </a:xfrm>
+          <a:prstGeom prst="rect">
+            <a:avLst/>
+          </a:prstGeom>
+          <a:noFill/>
+          <a:ln>
+            <a:solidFill>
+              <a:schemeClr val="accent1"/>
+            </a:solidFill>
+          </a:ln>
+        </p:spPr>
+        <p:txBody>
+          <a:bodyPr wrap="square" rtlCol="0">
+            <a:noAutofit/>
+          </a:bodyPr>
+          <a:lstStyle/>
+          <a:p>
+            <a:r>
+              <a:rPr lang="en-US" dirty="0"/>
+              <a:t>Start/Stop</a:t>
+            </a:r>
+          </a:p>
+        </p:txBody>
+      </p:sp>
+      <p:sp>
+        <p:nvSpPr>
+          <p:cNvPr id="61" name="TextBox 60">
+            <a:extLst>
+              <a:ext uri="{FF2B5EF4-FFF2-40B4-BE49-F238E27FC236}">
+                <a16:creationId xmlns:a16="http://schemas.microsoft.com/office/drawing/2014/main" id="{2267FC1D-E275-2725-17F6-FB456F60AD71}"/>
+              </a:ext>
+            </a:extLst>
+          </p:cNvPr>
+          <p:cNvSpPr txBox="1"/>
+          <p:nvPr/>
+        </p:nvSpPr>
+        <p:spPr>
+          <a:xfrm>
+            <a:off x="4774442" y="4349848"/>
+            <a:ext cx="1073400" cy="276999"/>
+          </a:xfrm>
+          <a:prstGeom prst="rect">
+            <a:avLst/>
+          </a:prstGeom>
+          <a:noFill/>
+        </p:spPr>
+        <p:txBody>
+          <a:bodyPr wrap="square" rtlCol="0">
+            <a:spAutoFit/>
+          </a:bodyPr>
+          <a:lstStyle/>
+          <a:p>
+            <a:r>
+              <a:rPr lang="en-US" sz="1200" dirty="0">
+                <a:solidFill>
+                  <a:srgbClr val="FF0000"/>
+                </a:solidFill>
+              </a:rPr>
+              <a:t>Grid-2 (1,1)</a:t>
+            </a:r>
+          </a:p>
+        </p:txBody>
+      </p:sp>
+      <p:sp>
+        <p:nvSpPr>
+          <p:cNvPr id="62" name="TextBox 61">
+            <a:extLst>
+              <a:ext uri="{FF2B5EF4-FFF2-40B4-BE49-F238E27FC236}">
+                <a16:creationId xmlns:a16="http://schemas.microsoft.com/office/drawing/2014/main" id="{012D3C87-5418-45D1-4FD3-DED8C867B1D9}"/>
+              </a:ext>
+            </a:extLst>
+          </p:cNvPr>
+          <p:cNvSpPr txBox="1"/>
+          <p:nvPr/>
+        </p:nvSpPr>
+        <p:spPr>
+          <a:xfrm>
+            <a:off x="4858147" y="5402093"/>
+            <a:ext cx="1073400" cy="276999"/>
+          </a:xfrm>
+          <a:prstGeom prst="rect">
+            <a:avLst/>
+          </a:prstGeom>
+          <a:noFill/>
+        </p:spPr>
+        <p:txBody>
+          <a:bodyPr wrap="square" rtlCol="0">
+            <a:spAutoFit/>
+          </a:bodyPr>
+          <a:lstStyle/>
+          <a:p>
+            <a:r>
+              <a:rPr lang="en-US" sz="1200" dirty="0">
+                <a:solidFill>
+                  <a:srgbClr val="FF0000"/>
+                </a:solidFill>
+              </a:rPr>
+              <a:t>Grid-2 (2,1)</a:t>
+            </a:r>
+          </a:p>
+        </p:txBody>
+      </p:sp>
+      <p:sp>
+        <p:nvSpPr>
+          <p:cNvPr id="63" name="Rectangle: Rounded Corners 62">
+            <a:extLst>
+              <a:ext uri="{FF2B5EF4-FFF2-40B4-BE49-F238E27FC236}">
+                <a16:creationId xmlns:a16="http://schemas.microsoft.com/office/drawing/2014/main" id="{0ADE5E4F-097C-C857-48D2-682C3565257C}"/>
+              </a:ext>
+            </a:extLst>
+          </p:cNvPr>
+          <p:cNvSpPr/>
+          <p:nvPr/>
+        </p:nvSpPr>
+        <p:spPr>
+          <a:xfrm>
+            <a:off x="3931214" y="1002676"/>
+            <a:ext cx="1376735" cy="2367847"/>
+          </a:xfrm>
+          <a:prstGeom prst="roundRect">
+            <a:avLst/>
+          </a:prstGeom>
+          <a:solidFill>
+            <a:schemeClr val="tx1"/>
+          </a:solidFill>
         </p:spPr>
         <p:style>
           <a:lnRef idx="2">
@@ -6915,136 +4691,68 @@
           <a:lstStyle/>
           <a:p>
             <a:pPr algn="ctr"/>
-            <a:endParaRPr lang="en-US"/>
-          </a:p>
-        </p:txBody>
-      </p:sp>
-      <p:sp>
-        <p:nvSpPr>
-          <p:cNvPr id="37" name="TextBox 36">
-            <a:extLst>
-              <a:ext uri="{FF2B5EF4-FFF2-40B4-BE49-F238E27FC236}">
-                <a16:creationId xmlns:a16="http://schemas.microsoft.com/office/drawing/2014/main" id="{B6397613-536D-67AC-DAAF-DC0F1B6F8161}"/>
-              </a:ext>
-            </a:extLst>
-          </p:cNvPr>
-          <p:cNvSpPr txBox="1"/>
+            <a:endParaRPr lang="en-US" dirty="0"/>
+          </a:p>
+        </p:txBody>
+      </p:sp>
+      <p:sp>
+        <p:nvSpPr>
+          <p:cNvPr id="64" name="Rectangle 63">
+            <a:extLst>
+              <a:ext uri="{FF2B5EF4-FFF2-40B4-BE49-F238E27FC236}">
+                <a16:creationId xmlns:a16="http://schemas.microsoft.com/office/drawing/2014/main" id="{3C58E37A-8CA7-8F1A-6A91-8B2D8A560B07}"/>
+              </a:ext>
+            </a:extLst>
+          </p:cNvPr>
+          <p:cNvSpPr/>
           <p:nvPr/>
         </p:nvSpPr>
         <p:spPr>
           <a:xfrm>
-            <a:off x="3251441" y="6531134"/>
-            <a:ext cx="1073400" cy="276999"/>
+            <a:off x="3333617" y="4738548"/>
+            <a:ext cx="2609379" cy="610759"/>
           </a:xfrm>
           <a:prstGeom prst="rect">
             <a:avLst/>
           </a:prstGeom>
           <a:noFill/>
         </p:spPr>
-        <p:txBody>
-          <a:bodyPr wrap="square" rtlCol="0">
-            <a:spAutoFit/>
-          </a:bodyPr>
-          <a:lstStyle/>
-          <a:p>
-            <a:r>
-              <a:rPr lang="en-US" sz="1200" dirty="0">
+        <p:style>
+          <a:lnRef idx="2">
+            <a:schemeClr val="accent1">
+              <a:shade val="15000"/>
+            </a:schemeClr>
+          </a:lnRef>
+          <a:fillRef idx="1">
+            <a:schemeClr val="accent1"/>
+          </a:fillRef>
+          <a:effectRef idx="0">
+            <a:schemeClr val="accent1"/>
+          </a:effectRef>
+          <a:fontRef idx="minor">
+            <a:schemeClr val="lt1"/>
+          </a:fontRef>
+        </p:style>
+        <p:txBody>
+          <a:bodyPr rtlCol="0" anchor="ctr"/>
+          <a:lstStyle/>
+          <a:p>
+            <a:pPr algn="ctr"/>
+            <a:r>
+              <a:rPr lang="en-US" sz="1400" dirty="0" err="1">
                 <a:solidFill>
-                  <a:srgbClr val="FF0000"/>
+                  <a:schemeClr val="tx1"/>
                 </a:solidFill>
               </a:rPr>
-              <a:t>Grid-1 (0,1)</a:t>
-            </a:r>
-          </a:p>
-        </p:txBody>
-      </p:sp>
-      <p:sp>
-        <p:nvSpPr>
-          <p:cNvPr id="40" name="TextBox 39">
-            <a:extLst>
-              <a:ext uri="{FF2B5EF4-FFF2-40B4-BE49-F238E27FC236}">
-                <a16:creationId xmlns:a16="http://schemas.microsoft.com/office/drawing/2014/main" id="{34464908-B2BC-12F5-AE64-322BFA626062}"/>
-              </a:ext>
-            </a:extLst>
-          </p:cNvPr>
-          <p:cNvSpPr txBox="1"/>
-          <p:nvPr/>
-        </p:nvSpPr>
-        <p:spPr>
-          <a:xfrm>
-            <a:off x="6204499" y="6188479"/>
-            <a:ext cx="2745975" cy="276999"/>
-          </a:xfrm>
-          <a:prstGeom prst="rect">
-            <a:avLst/>
-          </a:prstGeom>
-          <a:noFill/>
-        </p:spPr>
-        <p:txBody>
-          <a:bodyPr wrap="square" rtlCol="0">
-            <a:spAutoFit/>
-          </a:bodyPr>
-          <a:lstStyle/>
-          <a:p>
-            <a:r>
-              <a:rPr lang="en-US" sz="1200" dirty="0">
+              <a:t>ttk.Entry</a:t>
+            </a:r>
+            <a:r>
+              <a:rPr lang="en-US" sz="1400" dirty="0">
                 <a:solidFill>
-                  <a:srgbClr val="FF0000"/>
+                  <a:schemeClr val="tx1"/>
                 </a:solidFill>
               </a:rPr>
-              <a:t>Horizontal Scrollbar = Grid-3 </a:t>
-            </a:r>
-            <a:r>
-              <a:rPr lang="en-US" sz="1200">
-                <a:solidFill>
-                  <a:srgbClr val="FF0000"/>
-                </a:solidFill>
-              </a:rPr>
-              <a:t>(1,0-1)</a:t>
-            </a:r>
-            <a:endParaRPr lang="en-US" sz="1200" dirty="0">
-              <a:solidFill>
-                <a:srgbClr val="FF0000"/>
-              </a:solidFill>
-            </a:endParaRPr>
-          </a:p>
-        </p:txBody>
-      </p:sp>
-      <p:sp>
-        <p:nvSpPr>
-          <p:cNvPr id="43" name="TextBox 42">
-            <a:extLst>
-              <a:ext uri="{FF2B5EF4-FFF2-40B4-BE49-F238E27FC236}">
-                <a16:creationId xmlns:a16="http://schemas.microsoft.com/office/drawing/2014/main" id="{1AFADC8C-C279-B705-1C7D-BA80E1EB70E6}"/>
-              </a:ext>
-            </a:extLst>
-          </p:cNvPr>
-          <p:cNvSpPr txBox="1"/>
-          <p:nvPr/>
-        </p:nvSpPr>
-        <p:spPr>
-          <a:xfrm>
-            <a:off x="9264910" y="6167166"/>
-            <a:ext cx="2745975" cy="276999"/>
-          </a:xfrm>
-          <a:prstGeom prst="rect">
-            <a:avLst/>
-          </a:prstGeom>
-          <a:noFill/>
-        </p:spPr>
-        <p:txBody>
-          <a:bodyPr wrap="square" rtlCol="0">
-            <a:spAutoFit/>
-          </a:bodyPr>
-          <a:lstStyle/>
-          <a:p>
-            <a:r>
-              <a:rPr lang="en-US" sz="1200" dirty="0">
-                <a:solidFill>
-                  <a:srgbClr val="FF0000"/>
-                </a:solidFill>
-              </a:rPr>
-              <a:t>vertical Scrollbar = Grid-3 (0-1,1)</a:t>
+              <a:t> object, for entering the rhythm string that the metronome should follow</a:t>
             </a:r>
           </a:p>
         </p:txBody>
@@ -7052,7 +4760,7 @@
     </p:spTree>
     <p:extLst>
       <p:ext uri="{BB962C8B-B14F-4D97-AF65-F5344CB8AC3E}">
-        <p14:creationId xmlns:p14="http://schemas.microsoft.com/office/powerpoint/2010/main" val="3554569158"/>
+        <p14:creationId xmlns:p14="http://schemas.microsoft.com/office/powerpoint/2010/main" val="1356901432"/>
       </p:ext>
     </p:extLst>
   </p:cSld>

</xml_diff>